<commit_message>
python gui add programs And add & replace python provided
1. form submit with Label, Entry, Radiobutton, Checkbutton, OptionMenu, Button
2. withdraw(), deiconify() & destroy()
</commit_message>
<xml_diff>
--- a/Sem-2/Python/Python Provided/PPTs/DataFrames.pptx
+++ b/Sem-2/Python/Python Provided/PPTs/DataFrames.pptx
@@ -13,12 +13,13 @@
     <p:sldId id="266" r:id="rId7"/>
     <p:sldId id="267" r:id="rId8"/>
     <p:sldId id="270" r:id="rId9"/>
-    <p:sldId id="271" r:id="rId10"/>
-    <p:sldId id="275" r:id="rId11"/>
-    <p:sldId id="276" r:id="rId12"/>
-    <p:sldId id="273" r:id="rId13"/>
-    <p:sldId id="272" r:id="rId14"/>
-    <p:sldId id="274" r:id="rId15"/>
+    <p:sldId id="277" r:id="rId10"/>
+    <p:sldId id="271" r:id="rId11"/>
+    <p:sldId id="275" r:id="rId12"/>
+    <p:sldId id="276" r:id="rId13"/>
+    <p:sldId id="273" r:id="rId14"/>
+    <p:sldId id="272" r:id="rId15"/>
+    <p:sldId id="274" r:id="rId16"/>
   </p:sldIdLst>
   <p:sldSz cx="12192000" cy="6858000"/>
   <p:notesSz cx="6858000" cy="9144000"/>
@@ -147,7 +148,7 @@
           <p:cNvPr id="2" name="Title 1">
             <a:extLst>
               <a:ext uri="{FF2B5EF4-FFF2-40B4-BE49-F238E27FC236}">
-                <a16:creationId xmlns="" xmlns:a16="http://schemas.microsoft.com/office/drawing/2014/main" id="{4D96F151-6DBA-8632-87AC-2C663DCC5A1D}"/>
+                <a16:creationId xmlns:a16="http://schemas.microsoft.com/office/drawing/2014/main" xmlns="" id="{4D96F151-6DBA-8632-87AC-2C663DCC5A1D}"/>
               </a:ext>
             </a:extLst>
           </p:cNvPr>
@@ -185,7 +186,7 @@
           <p:cNvPr id="3" name="Subtitle 2">
             <a:extLst>
               <a:ext uri="{FF2B5EF4-FFF2-40B4-BE49-F238E27FC236}">
-                <a16:creationId xmlns="" xmlns:a16="http://schemas.microsoft.com/office/drawing/2014/main" id="{F60E65FA-3EE2-4BBF-6883-31129496825C}"/>
+                <a16:creationId xmlns:a16="http://schemas.microsoft.com/office/drawing/2014/main" xmlns="" id="{F60E65FA-3EE2-4BBF-6883-31129496825C}"/>
               </a:ext>
             </a:extLst>
           </p:cNvPr>
@@ -256,7 +257,7 @@
           <p:cNvPr id="4" name="Date Placeholder 3">
             <a:extLst>
               <a:ext uri="{FF2B5EF4-FFF2-40B4-BE49-F238E27FC236}">
-                <a16:creationId xmlns="" xmlns:a16="http://schemas.microsoft.com/office/drawing/2014/main" id="{927B1AA2-04E5-335D-F03F-E6C1572BB4A6}"/>
+                <a16:creationId xmlns:a16="http://schemas.microsoft.com/office/drawing/2014/main" xmlns="" id="{927B1AA2-04E5-335D-F03F-E6C1572BB4A6}"/>
               </a:ext>
             </a:extLst>
           </p:cNvPr>
@@ -274,7 +275,7 @@
           <a:p>
             <a:fld id="{645F78BF-CFA7-4921-A841-16C011F814A2}" type="datetimeFigureOut">
               <a:rPr lang="en-IN" smtClean="0"/>
-              <a:t>09-04-2025</a:t>
+              <a:t>02-04-2026</a:t>
             </a:fld>
             <a:endParaRPr lang="en-IN"/>
           </a:p>
@@ -285,7 +286,7 @@
           <p:cNvPr id="5" name="Footer Placeholder 4">
             <a:extLst>
               <a:ext uri="{FF2B5EF4-FFF2-40B4-BE49-F238E27FC236}">
-                <a16:creationId xmlns="" xmlns:a16="http://schemas.microsoft.com/office/drawing/2014/main" id="{1A0C3F63-2393-CCA7-822A-1BBAB1CD8130}"/>
+                <a16:creationId xmlns:a16="http://schemas.microsoft.com/office/drawing/2014/main" xmlns="" id="{1A0C3F63-2393-CCA7-822A-1BBAB1CD8130}"/>
               </a:ext>
             </a:extLst>
           </p:cNvPr>
@@ -310,7 +311,7 @@
           <p:cNvPr id="6" name="Slide Number Placeholder 5">
             <a:extLst>
               <a:ext uri="{FF2B5EF4-FFF2-40B4-BE49-F238E27FC236}">
-                <a16:creationId xmlns="" xmlns:a16="http://schemas.microsoft.com/office/drawing/2014/main" id="{3B24A2A8-EA9B-490E-051C-60D0BAB4407E}"/>
+                <a16:creationId xmlns:a16="http://schemas.microsoft.com/office/drawing/2014/main" xmlns="" id="{3B24A2A8-EA9B-490E-051C-60D0BAB4407E}"/>
               </a:ext>
             </a:extLst>
           </p:cNvPr>
@@ -369,7 +370,7 @@
           <p:cNvPr id="2" name="Title 1">
             <a:extLst>
               <a:ext uri="{FF2B5EF4-FFF2-40B4-BE49-F238E27FC236}">
-                <a16:creationId xmlns="" xmlns:a16="http://schemas.microsoft.com/office/drawing/2014/main" id="{277D3AA3-8549-B65D-BA2C-77EB0745ABE9}"/>
+                <a16:creationId xmlns:a16="http://schemas.microsoft.com/office/drawing/2014/main" xmlns="" id="{277D3AA3-8549-B65D-BA2C-77EB0745ABE9}"/>
               </a:ext>
             </a:extLst>
           </p:cNvPr>
@@ -398,7 +399,7 @@
           <p:cNvPr id="3" name="Vertical Text Placeholder 2">
             <a:extLst>
               <a:ext uri="{FF2B5EF4-FFF2-40B4-BE49-F238E27FC236}">
-                <a16:creationId xmlns="" xmlns:a16="http://schemas.microsoft.com/office/drawing/2014/main" id="{2B41F54B-14DE-418F-96F9-39AF070D8B20}"/>
+                <a16:creationId xmlns:a16="http://schemas.microsoft.com/office/drawing/2014/main" xmlns="" id="{2B41F54B-14DE-418F-96F9-39AF070D8B20}"/>
               </a:ext>
             </a:extLst>
           </p:cNvPr>
@@ -456,7 +457,7 @@
           <p:cNvPr id="4" name="Date Placeholder 3">
             <a:extLst>
               <a:ext uri="{FF2B5EF4-FFF2-40B4-BE49-F238E27FC236}">
-                <a16:creationId xmlns="" xmlns:a16="http://schemas.microsoft.com/office/drawing/2014/main" id="{F8F8314A-05EB-702B-67F9-B6B62B33B17E}"/>
+                <a16:creationId xmlns:a16="http://schemas.microsoft.com/office/drawing/2014/main" xmlns="" id="{F8F8314A-05EB-702B-67F9-B6B62B33B17E}"/>
               </a:ext>
             </a:extLst>
           </p:cNvPr>
@@ -474,7 +475,7 @@
           <a:p>
             <a:fld id="{645F78BF-CFA7-4921-A841-16C011F814A2}" type="datetimeFigureOut">
               <a:rPr lang="en-IN" smtClean="0"/>
-              <a:t>09-04-2025</a:t>
+              <a:t>02-04-2026</a:t>
             </a:fld>
             <a:endParaRPr lang="en-IN"/>
           </a:p>
@@ -485,7 +486,7 @@
           <p:cNvPr id="5" name="Footer Placeholder 4">
             <a:extLst>
               <a:ext uri="{FF2B5EF4-FFF2-40B4-BE49-F238E27FC236}">
-                <a16:creationId xmlns="" xmlns:a16="http://schemas.microsoft.com/office/drawing/2014/main" id="{1F891070-4DB4-A737-F8CF-57450707F001}"/>
+                <a16:creationId xmlns:a16="http://schemas.microsoft.com/office/drawing/2014/main" xmlns="" id="{1F891070-4DB4-A737-F8CF-57450707F001}"/>
               </a:ext>
             </a:extLst>
           </p:cNvPr>
@@ -510,7 +511,7 @@
           <p:cNvPr id="6" name="Slide Number Placeholder 5">
             <a:extLst>
               <a:ext uri="{FF2B5EF4-FFF2-40B4-BE49-F238E27FC236}">
-                <a16:creationId xmlns="" xmlns:a16="http://schemas.microsoft.com/office/drawing/2014/main" id="{5ACB2D62-AD1F-C0CA-37CA-553DE3952929}"/>
+                <a16:creationId xmlns:a16="http://schemas.microsoft.com/office/drawing/2014/main" xmlns="" id="{5ACB2D62-AD1F-C0CA-37CA-553DE3952929}"/>
               </a:ext>
             </a:extLst>
           </p:cNvPr>
@@ -569,7 +570,7 @@
           <p:cNvPr id="2" name="Vertical Title 1">
             <a:extLst>
               <a:ext uri="{FF2B5EF4-FFF2-40B4-BE49-F238E27FC236}">
-                <a16:creationId xmlns="" xmlns:a16="http://schemas.microsoft.com/office/drawing/2014/main" id="{0A6D93B9-89B1-DE84-BC48-D32FACCA58A1}"/>
+                <a16:creationId xmlns:a16="http://schemas.microsoft.com/office/drawing/2014/main" xmlns="" id="{0A6D93B9-89B1-DE84-BC48-D32FACCA58A1}"/>
               </a:ext>
             </a:extLst>
           </p:cNvPr>
@@ -603,7 +604,7 @@
           <p:cNvPr id="3" name="Vertical Text Placeholder 2">
             <a:extLst>
               <a:ext uri="{FF2B5EF4-FFF2-40B4-BE49-F238E27FC236}">
-                <a16:creationId xmlns="" xmlns:a16="http://schemas.microsoft.com/office/drawing/2014/main" id="{1BFE847B-00BF-EBD0-9DA3-65599640DA6F}"/>
+                <a16:creationId xmlns:a16="http://schemas.microsoft.com/office/drawing/2014/main" xmlns="" id="{1BFE847B-00BF-EBD0-9DA3-65599640DA6F}"/>
               </a:ext>
             </a:extLst>
           </p:cNvPr>
@@ -666,7 +667,7 @@
           <p:cNvPr id="4" name="Date Placeholder 3">
             <a:extLst>
               <a:ext uri="{FF2B5EF4-FFF2-40B4-BE49-F238E27FC236}">
-                <a16:creationId xmlns="" xmlns:a16="http://schemas.microsoft.com/office/drawing/2014/main" id="{B16F9C36-DF44-C604-01FD-B32695E06C16}"/>
+                <a16:creationId xmlns:a16="http://schemas.microsoft.com/office/drawing/2014/main" xmlns="" id="{B16F9C36-DF44-C604-01FD-B32695E06C16}"/>
               </a:ext>
             </a:extLst>
           </p:cNvPr>
@@ -684,7 +685,7 @@
           <a:p>
             <a:fld id="{645F78BF-CFA7-4921-A841-16C011F814A2}" type="datetimeFigureOut">
               <a:rPr lang="en-IN" smtClean="0"/>
-              <a:t>09-04-2025</a:t>
+              <a:t>02-04-2026</a:t>
             </a:fld>
             <a:endParaRPr lang="en-IN"/>
           </a:p>
@@ -695,7 +696,7 @@
           <p:cNvPr id="5" name="Footer Placeholder 4">
             <a:extLst>
               <a:ext uri="{FF2B5EF4-FFF2-40B4-BE49-F238E27FC236}">
-                <a16:creationId xmlns="" xmlns:a16="http://schemas.microsoft.com/office/drawing/2014/main" id="{390363E5-A9F9-85F8-668A-4B521A79F7F7}"/>
+                <a16:creationId xmlns:a16="http://schemas.microsoft.com/office/drawing/2014/main" xmlns="" id="{390363E5-A9F9-85F8-668A-4B521A79F7F7}"/>
               </a:ext>
             </a:extLst>
           </p:cNvPr>
@@ -720,7 +721,7 @@
           <p:cNvPr id="6" name="Slide Number Placeholder 5">
             <a:extLst>
               <a:ext uri="{FF2B5EF4-FFF2-40B4-BE49-F238E27FC236}">
-                <a16:creationId xmlns="" xmlns:a16="http://schemas.microsoft.com/office/drawing/2014/main" id="{37A1E565-8754-4117-E897-0E3AD3C357DB}"/>
+                <a16:creationId xmlns:a16="http://schemas.microsoft.com/office/drawing/2014/main" xmlns="" id="{37A1E565-8754-4117-E897-0E3AD3C357DB}"/>
               </a:ext>
             </a:extLst>
           </p:cNvPr>
@@ -779,7 +780,7 @@
           <p:cNvPr id="2" name="Title 1">
             <a:extLst>
               <a:ext uri="{FF2B5EF4-FFF2-40B4-BE49-F238E27FC236}">
-                <a16:creationId xmlns="" xmlns:a16="http://schemas.microsoft.com/office/drawing/2014/main" id="{8DAB3E84-52B2-2DA7-BDC1-0430F6159F9C}"/>
+                <a16:creationId xmlns:a16="http://schemas.microsoft.com/office/drawing/2014/main" xmlns="" id="{8DAB3E84-52B2-2DA7-BDC1-0430F6159F9C}"/>
               </a:ext>
             </a:extLst>
           </p:cNvPr>
@@ -808,7 +809,7 @@
           <p:cNvPr id="3" name="Content Placeholder 2">
             <a:extLst>
               <a:ext uri="{FF2B5EF4-FFF2-40B4-BE49-F238E27FC236}">
-                <a16:creationId xmlns="" xmlns:a16="http://schemas.microsoft.com/office/drawing/2014/main" id="{BAEC0D5A-311C-441C-14E3-8A645216165D}"/>
+                <a16:creationId xmlns:a16="http://schemas.microsoft.com/office/drawing/2014/main" xmlns="" id="{BAEC0D5A-311C-441C-14E3-8A645216165D}"/>
               </a:ext>
             </a:extLst>
           </p:cNvPr>
@@ -866,7 +867,7 @@
           <p:cNvPr id="4" name="Date Placeholder 3">
             <a:extLst>
               <a:ext uri="{FF2B5EF4-FFF2-40B4-BE49-F238E27FC236}">
-                <a16:creationId xmlns="" xmlns:a16="http://schemas.microsoft.com/office/drawing/2014/main" id="{2BB0AB3B-988C-8F1A-7F3C-2370CE7CF1D1}"/>
+                <a16:creationId xmlns:a16="http://schemas.microsoft.com/office/drawing/2014/main" xmlns="" id="{2BB0AB3B-988C-8F1A-7F3C-2370CE7CF1D1}"/>
               </a:ext>
             </a:extLst>
           </p:cNvPr>
@@ -884,7 +885,7 @@
           <a:p>
             <a:fld id="{645F78BF-CFA7-4921-A841-16C011F814A2}" type="datetimeFigureOut">
               <a:rPr lang="en-IN" smtClean="0"/>
-              <a:t>09-04-2025</a:t>
+              <a:t>02-04-2026</a:t>
             </a:fld>
             <a:endParaRPr lang="en-IN"/>
           </a:p>
@@ -895,7 +896,7 @@
           <p:cNvPr id="5" name="Footer Placeholder 4">
             <a:extLst>
               <a:ext uri="{FF2B5EF4-FFF2-40B4-BE49-F238E27FC236}">
-                <a16:creationId xmlns="" xmlns:a16="http://schemas.microsoft.com/office/drawing/2014/main" id="{02C0A4D1-5D52-44A8-21E6-01EB5836FB2A}"/>
+                <a16:creationId xmlns:a16="http://schemas.microsoft.com/office/drawing/2014/main" xmlns="" id="{02C0A4D1-5D52-44A8-21E6-01EB5836FB2A}"/>
               </a:ext>
             </a:extLst>
           </p:cNvPr>
@@ -920,7 +921,7 @@
           <p:cNvPr id="6" name="Slide Number Placeholder 5">
             <a:extLst>
               <a:ext uri="{FF2B5EF4-FFF2-40B4-BE49-F238E27FC236}">
-                <a16:creationId xmlns="" xmlns:a16="http://schemas.microsoft.com/office/drawing/2014/main" id="{0C0D5253-290D-71D2-E043-C5E8B51D7F07}"/>
+                <a16:creationId xmlns:a16="http://schemas.microsoft.com/office/drawing/2014/main" xmlns="" id="{0C0D5253-290D-71D2-E043-C5E8B51D7F07}"/>
               </a:ext>
             </a:extLst>
           </p:cNvPr>
@@ -979,7 +980,7 @@
           <p:cNvPr id="2" name="Title 1">
             <a:extLst>
               <a:ext uri="{FF2B5EF4-FFF2-40B4-BE49-F238E27FC236}">
-                <a16:creationId xmlns="" xmlns:a16="http://schemas.microsoft.com/office/drawing/2014/main" id="{0CA63316-5A13-723A-0C8E-2490F9E33E1F}"/>
+                <a16:creationId xmlns:a16="http://schemas.microsoft.com/office/drawing/2014/main" xmlns="" id="{0CA63316-5A13-723A-0C8E-2490F9E33E1F}"/>
               </a:ext>
             </a:extLst>
           </p:cNvPr>
@@ -1017,7 +1018,7 @@
           <p:cNvPr id="3" name="Text Placeholder 2">
             <a:extLst>
               <a:ext uri="{FF2B5EF4-FFF2-40B4-BE49-F238E27FC236}">
-                <a16:creationId xmlns="" xmlns:a16="http://schemas.microsoft.com/office/drawing/2014/main" id="{9852581C-287B-92EE-32D1-829C026746EA}"/>
+                <a16:creationId xmlns:a16="http://schemas.microsoft.com/office/drawing/2014/main" xmlns="" id="{9852581C-287B-92EE-32D1-829C026746EA}"/>
               </a:ext>
             </a:extLst>
           </p:cNvPr>
@@ -1142,7 +1143,7 @@
           <p:cNvPr id="4" name="Date Placeholder 3">
             <a:extLst>
               <a:ext uri="{FF2B5EF4-FFF2-40B4-BE49-F238E27FC236}">
-                <a16:creationId xmlns="" xmlns:a16="http://schemas.microsoft.com/office/drawing/2014/main" id="{B5C1D1B5-AD78-BB9C-89CB-E56C1EE89CB9}"/>
+                <a16:creationId xmlns:a16="http://schemas.microsoft.com/office/drawing/2014/main" xmlns="" id="{B5C1D1B5-AD78-BB9C-89CB-E56C1EE89CB9}"/>
               </a:ext>
             </a:extLst>
           </p:cNvPr>
@@ -1160,7 +1161,7 @@
           <a:p>
             <a:fld id="{645F78BF-CFA7-4921-A841-16C011F814A2}" type="datetimeFigureOut">
               <a:rPr lang="en-IN" smtClean="0"/>
-              <a:t>09-04-2025</a:t>
+              <a:t>02-04-2026</a:t>
             </a:fld>
             <a:endParaRPr lang="en-IN"/>
           </a:p>
@@ -1171,7 +1172,7 @@
           <p:cNvPr id="5" name="Footer Placeholder 4">
             <a:extLst>
               <a:ext uri="{FF2B5EF4-FFF2-40B4-BE49-F238E27FC236}">
-                <a16:creationId xmlns="" xmlns:a16="http://schemas.microsoft.com/office/drawing/2014/main" id="{2331611B-2EE3-1C99-DF83-E6BDC0721A4D}"/>
+                <a16:creationId xmlns:a16="http://schemas.microsoft.com/office/drawing/2014/main" xmlns="" id="{2331611B-2EE3-1C99-DF83-E6BDC0721A4D}"/>
               </a:ext>
             </a:extLst>
           </p:cNvPr>
@@ -1196,7 +1197,7 @@
           <p:cNvPr id="6" name="Slide Number Placeholder 5">
             <a:extLst>
               <a:ext uri="{FF2B5EF4-FFF2-40B4-BE49-F238E27FC236}">
-                <a16:creationId xmlns="" xmlns:a16="http://schemas.microsoft.com/office/drawing/2014/main" id="{06136829-8AF5-4546-8DEF-C4D730D4927A}"/>
+                <a16:creationId xmlns:a16="http://schemas.microsoft.com/office/drawing/2014/main" xmlns="" id="{06136829-8AF5-4546-8DEF-C4D730D4927A}"/>
               </a:ext>
             </a:extLst>
           </p:cNvPr>
@@ -1255,7 +1256,7 @@
           <p:cNvPr id="2" name="Title 1">
             <a:extLst>
               <a:ext uri="{FF2B5EF4-FFF2-40B4-BE49-F238E27FC236}">
-                <a16:creationId xmlns="" xmlns:a16="http://schemas.microsoft.com/office/drawing/2014/main" id="{0CE48BDD-8A44-92C1-CA9E-EBE69E5F4BF1}"/>
+                <a16:creationId xmlns:a16="http://schemas.microsoft.com/office/drawing/2014/main" xmlns="" id="{0CE48BDD-8A44-92C1-CA9E-EBE69E5F4BF1}"/>
               </a:ext>
             </a:extLst>
           </p:cNvPr>
@@ -1284,7 +1285,7 @@
           <p:cNvPr id="3" name="Content Placeholder 2">
             <a:extLst>
               <a:ext uri="{FF2B5EF4-FFF2-40B4-BE49-F238E27FC236}">
-                <a16:creationId xmlns="" xmlns:a16="http://schemas.microsoft.com/office/drawing/2014/main" id="{78DA6F13-EBE1-20CF-041B-CA7C313B5999}"/>
+                <a16:creationId xmlns:a16="http://schemas.microsoft.com/office/drawing/2014/main" xmlns="" id="{78DA6F13-EBE1-20CF-041B-CA7C313B5999}"/>
               </a:ext>
             </a:extLst>
           </p:cNvPr>
@@ -1347,7 +1348,7 @@
           <p:cNvPr id="4" name="Content Placeholder 3">
             <a:extLst>
               <a:ext uri="{FF2B5EF4-FFF2-40B4-BE49-F238E27FC236}">
-                <a16:creationId xmlns="" xmlns:a16="http://schemas.microsoft.com/office/drawing/2014/main" id="{EA3BCDE0-BACC-1A06-0C57-F934DFE74971}"/>
+                <a16:creationId xmlns:a16="http://schemas.microsoft.com/office/drawing/2014/main" xmlns="" id="{EA3BCDE0-BACC-1A06-0C57-F934DFE74971}"/>
               </a:ext>
             </a:extLst>
           </p:cNvPr>
@@ -1410,7 +1411,7 @@
           <p:cNvPr id="5" name="Date Placeholder 4">
             <a:extLst>
               <a:ext uri="{FF2B5EF4-FFF2-40B4-BE49-F238E27FC236}">
-                <a16:creationId xmlns="" xmlns:a16="http://schemas.microsoft.com/office/drawing/2014/main" id="{FE458220-A309-6548-2FC3-23E41C1C8D42}"/>
+                <a16:creationId xmlns:a16="http://schemas.microsoft.com/office/drawing/2014/main" xmlns="" id="{FE458220-A309-6548-2FC3-23E41C1C8D42}"/>
               </a:ext>
             </a:extLst>
           </p:cNvPr>
@@ -1428,7 +1429,7 @@
           <a:p>
             <a:fld id="{645F78BF-CFA7-4921-A841-16C011F814A2}" type="datetimeFigureOut">
               <a:rPr lang="en-IN" smtClean="0"/>
-              <a:t>09-04-2025</a:t>
+              <a:t>02-04-2026</a:t>
             </a:fld>
             <a:endParaRPr lang="en-IN"/>
           </a:p>
@@ -1439,7 +1440,7 @@
           <p:cNvPr id="6" name="Footer Placeholder 5">
             <a:extLst>
               <a:ext uri="{FF2B5EF4-FFF2-40B4-BE49-F238E27FC236}">
-                <a16:creationId xmlns="" xmlns:a16="http://schemas.microsoft.com/office/drawing/2014/main" id="{F030D6CA-3C1F-DF47-4A60-C415E2A8F3CD}"/>
+                <a16:creationId xmlns:a16="http://schemas.microsoft.com/office/drawing/2014/main" xmlns="" id="{F030D6CA-3C1F-DF47-4A60-C415E2A8F3CD}"/>
               </a:ext>
             </a:extLst>
           </p:cNvPr>
@@ -1464,7 +1465,7 @@
           <p:cNvPr id="7" name="Slide Number Placeholder 6">
             <a:extLst>
               <a:ext uri="{FF2B5EF4-FFF2-40B4-BE49-F238E27FC236}">
-                <a16:creationId xmlns="" xmlns:a16="http://schemas.microsoft.com/office/drawing/2014/main" id="{468E826F-C41F-EC76-00BA-578B87268E62}"/>
+                <a16:creationId xmlns:a16="http://schemas.microsoft.com/office/drawing/2014/main" xmlns="" id="{468E826F-C41F-EC76-00BA-578B87268E62}"/>
               </a:ext>
             </a:extLst>
           </p:cNvPr>
@@ -1523,7 +1524,7 @@
           <p:cNvPr id="2" name="Title 1">
             <a:extLst>
               <a:ext uri="{FF2B5EF4-FFF2-40B4-BE49-F238E27FC236}">
-                <a16:creationId xmlns="" xmlns:a16="http://schemas.microsoft.com/office/drawing/2014/main" id="{489D6B4F-5936-B3CF-9DD2-EAC2104F8F0E}"/>
+                <a16:creationId xmlns:a16="http://schemas.microsoft.com/office/drawing/2014/main" xmlns="" id="{489D6B4F-5936-B3CF-9DD2-EAC2104F8F0E}"/>
               </a:ext>
             </a:extLst>
           </p:cNvPr>
@@ -1557,7 +1558,7 @@
           <p:cNvPr id="3" name="Text Placeholder 2">
             <a:extLst>
               <a:ext uri="{FF2B5EF4-FFF2-40B4-BE49-F238E27FC236}">
-                <a16:creationId xmlns="" xmlns:a16="http://schemas.microsoft.com/office/drawing/2014/main" id="{A3319611-A7D4-D26D-0187-F894114023EB}"/>
+                <a16:creationId xmlns:a16="http://schemas.microsoft.com/office/drawing/2014/main" xmlns="" id="{A3319611-A7D4-D26D-0187-F894114023EB}"/>
               </a:ext>
             </a:extLst>
           </p:cNvPr>
@@ -1628,7 +1629,7 @@
           <p:cNvPr id="4" name="Content Placeholder 3">
             <a:extLst>
               <a:ext uri="{FF2B5EF4-FFF2-40B4-BE49-F238E27FC236}">
-                <a16:creationId xmlns="" xmlns:a16="http://schemas.microsoft.com/office/drawing/2014/main" id="{7F835843-0B7C-E86E-9B30-11F0004BA136}"/>
+                <a16:creationId xmlns:a16="http://schemas.microsoft.com/office/drawing/2014/main" xmlns="" id="{7F835843-0B7C-E86E-9B30-11F0004BA136}"/>
               </a:ext>
             </a:extLst>
           </p:cNvPr>
@@ -1691,7 +1692,7 @@
           <p:cNvPr id="5" name="Text Placeholder 4">
             <a:extLst>
               <a:ext uri="{FF2B5EF4-FFF2-40B4-BE49-F238E27FC236}">
-                <a16:creationId xmlns="" xmlns:a16="http://schemas.microsoft.com/office/drawing/2014/main" id="{3E4071AB-7606-11B5-CA60-57CAF73ACCEF}"/>
+                <a16:creationId xmlns:a16="http://schemas.microsoft.com/office/drawing/2014/main" xmlns="" id="{3E4071AB-7606-11B5-CA60-57CAF73ACCEF}"/>
               </a:ext>
             </a:extLst>
           </p:cNvPr>
@@ -1762,7 +1763,7 @@
           <p:cNvPr id="6" name="Content Placeholder 5">
             <a:extLst>
               <a:ext uri="{FF2B5EF4-FFF2-40B4-BE49-F238E27FC236}">
-                <a16:creationId xmlns="" xmlns:a16="http://schemas.microsoft.com/office/drawing/2014/main" id="{1CD3D967-7A4C-5F83-835C-AFB2AD732DB7}"/>
+                <a16:creationId xmlns:a16="http://schemas.microsoft.com/office/drawing/2014/main" xmlns="" id="{1CD3D967-7A4C-5F83-835C-AFB2AD732DB7}"/>
               </a:ext>
             </a:extLst>
           </p:cNvPr>
@@ -1825,7 +1826,7 @@
           <p:cNvPr id="7" name="Date Placeholder 6">
             <a:extLst>
               <a:ext uri="{FF2B5EF4-FFF2-40B4-BE49-F238E27FC236}">
-                <a16:creationId xmlns="" xmlns:a16="http://schemas.microsoft.com/office/drawing/2014/main" id="{97D7BE08-8218-C0F3-3C9B-AE97736BC93E}"/>
+                <a16:creationId xmlns:a16="http://schemas.microsoft.com/office/drawing/2014/main" xmlns="" id="{97D7BE08-8218-C0F3-3C9B-AE97736BC93E}"/>
               </a:ext>
             </a:extLst>
           </p:cNvPr>
@@ -1843,7 +1844,7 @@
           <a:p>
             <a:fld id="{645F78BF-CFA7-4921-A841-16C011F814A2}" type="datetimeFigureOut">
               <a:rPr lang="en-IN" smtClean="0"/>
-              <a:t>09-04-2025</a:t>
+              <a:t>02-04-2026</a:t>
             </a:fld>
             <a:endParaRPr lang="en-IN"/>
           </a:p>
@@ -1854,7 +1855,7 @@
           <p:cNvPr id="8" name="Footer Placeholder 7">
             <a:extLst>
               <a:ext uri="{FF2B5EF4-FFF2-40B4-BE49-F238E27FC236}">
-                <a16:creationId xmlns="" xmlns:a16="http://schemas.microsoft.com/office/drawing/2014/main" id="{6143C0EE-16DF-6EE7-155E-4334269E8F67}"/>
+                <a16:creationId xmlns:a16="http://schemas.microsoft.com/office/drawing/2014/main" xmlns="" id="{6143C0EE-16DF-6EE7-155E-4334269E8F67}"/>
               </a:ext>
             </a:extLst>
           </p:cNvPr>
@@ -1879,7 +1880,7 @@
           <p:cNvPr id="9" name="Slide Number Placeholder 8">
             <a:extLst>
               <a:ext uri="{FF2B5EF4-FFF2-40B4-BE49-F238E27FC236}">
-                <a16:creationId xmlns="" xmlns:a16="http://schemas.microsoft.com/office/drawing/2014/main" id="{867B40EC-C376-9352-DAF6-7D2011BF52D8}"/>
+                <a16:creationId xmlns:a16="http://schemas.microsoft.com/office/drawing/2014/main" xmlns="" id="{867B40EC-C376-9352-DAF6-7D2011BF52D8}"/>
               </a:ext>
             </a:extLst>
           </p:cNvPr>
@@ -1938,7 +1939,7 @@
           <p:cNvPr id="2" name="Title 1">
             <a:extLst>
               <a:ext uri="{FF2B5EF4-FFF2-40B4-BE49-F238E27FC236}">
-                <a16:creationId xmlns="" xmlns:a16="http://schemas.microsoft.com/office/drawing/2014/main" id="{D6033525-93BD-B8F8-D87E-479AC5E39BA9}"/>
+                <a16:creationId xmlns:a16="http://schemas.microsoft.com/office/drawing/2014/main" xmlns="" id="{D6033525-93BD-B8F8-D87E-479AC5E39BA9}"/>
               </a:ext>
             </a:extLst>
           </p:cNvPr>
@@ -1967,7 +1968,7 @@
           <p:cNvPr id="3" name="Date Placeholder 2">
             <a:extLst>
               <a:ext uri="{FF2B5EF4-FFF2-40B4-BE49-F238E27FC236}">
-                <a16:creationId xmlns="" xmlns:a16="http://schemas.microsoft.com/office/drawing/2014/main" id="{0E32AC5D-210F-5A4F-BB78-FA032A1D0F5E}"/>
+                <a16:creationId xmlns:a16="http://schemas.microsoft.com/office/drawing/2014/main" xmlns="" id="{0E32AC5D-210F-5A4F-BB78-FA032A1D0F5E}"/>
               </a:ext>
             </a:extLst>
           </p:cNvPr>
@@ -1985,7 +1986,7 @@
           <a:p>
             <a:fld id="{645F78BF-CFA7-4921-A841-16C011F814A2}" type="datetimeFigureOut">
               <a:rPr lang="en-IN" smtClean="0"/>
-              <a:t>09-04-2025</a:t>
+              <a:t>02-04-2026</a:t>
             </a:fld>
             <a:endParaRPr lang="en-IN"/>
           </a:p>
@@ -1996,7 +1997,7 @@
           <p:cNvPr id="4" name="Footer Placeholder 3">
             <a:extLst>
               <a:ext uri="{FF2B5EF4-FFF2-40B4-BE49-F238E27FC236}">
-                <a16:creationId xmlns="" xmlns:a16="http://schemas.microsoft.com/office/drawing/2014/main" id="{62B39E5E-BE21-8793-C560-7368A7E915DC}"/>
+                <a16:creationId xmlns:a16="http://schemas.microsoft.com/office/drawing/2014/main" xmlns="" id="{62B39E5E-BE21-8793-C560-7368A7E915DC}"/>
               </a:ext>
             </a:extLst>
           </p:cNvPr>
@@ -2021,7 +2022,7 @@
           <p:cNvPr id="5" name="Slide Number Placeholder 4">
             <a:extLst>
               <a:ext uri="{FF2B5EF4-FFF2-40B4-BE49-F238E27FC236}">
-                <a16:creationId xmlns="" xmlns:a16="http://schemas.microsoft.com/office/drawing/2014/main" id="{C13C95D6-2A53-64E7-DE51-D81BB96EFCD9}"/>
+                <a16:creationId xmlns:a16="http://schemas.microsoft.com/office/drawing/2014/main" xmlns="" id="{C13C95D6-2A53-64E7-DE51-D81BB96EFCD9}"/>
               </a:ext>
             </a:extLst>
           </p:cNvPr>
@@ -2080,7 +2081,7 @@
           <p:cNvPr id="2" name="Date Placeholder 1">
             <a:extLst>
               <a:ext uri="{FF2B5EF4-FFF2-40B4-BE49-F238E27FC236}">
-                <a16:creationId xmlns="" xmlns:a16="http://schemas.microsoft.com/office/drawing/2014/main" id="{E238BFB9-578B-B569-7E54-31EED14E2674}"/>
+                <a16:creationId xmlns:a16="http://schemas.microsoft.com/office/drawing/2014/main" xmlns="" id="{E238BFB9-578B-B569-7E54-31EED14E2674}"/>
               </a:ext>
             </a:extLst>
           </p:cNvPr>
@@ -2098,7 +2099,7 @@
           <a:p>
             <a:fld id="{645F78BF-CFA7-4921-A841-16C011F814A2}" type="datetimeFigureOut">
               <a:rPr lang="en-IN" smtClean="0"/>
-              <a:t>09-04-2025</a:t>
+              <a:t>02-04-2026</a:t>
             </a:fld>
             <a:endParaRPr lang="en-IN"/>
           </a:p>
@@ -2109,7 +2110,7 @@
           <p:cNvPr id="3" name="Footer Placeholder 2">
             <a:extLst>
               <a:ext uri="{FF2B5EF4-FFF2-40B4-BE49-F238E27FC236}">
-                <a16:creationId xmlns="" xmlns:a16="http://schemas.microsoft.com/office/drawing/2014/main" id="{5F338C01-2BCA-FD1C-2F72-E9C060758500}"/>
+                <a16:creationId xmlns:a16="http://schemas.microsoft.com/office/drawing/2014/main" xmlns="" id="{5F338C01-2BCA-FD1C-2F72-E9C060758500}"/>
               </a:ext>
             </a:extLst>
           </p:cNvPr>
@@ -2134,7 +2135,7 @@
           <p:cNvPr id="4" name="Slide Number Placeholder 3">
             <a:extLst>
               <a:ext uri="{FF2B5EF4-FFF2-40B4-BE49-F238E27FC236}">
-                <a16:creationId xmlns="" xmlns:a16="http://schemas.microsoft.com/office/drawing/2014/main" id="{892DCBBF-15F0-7943-F759-3A058510330B}"/>
+                <a16:creationId xmlns:a16="http://schemas.microsoft.com/office/drawing/2014/main" xmlns="" id="{892DCBBF-15F0-7943-F759-3A058510330B}"/>
               </a:ext>
             </a:extLst>
           </p:cNvPr>
@@ -2193,7 +2194,7 @@
           <p:cNvPr id="2" name="Title 1">
             <a:extLst>
               <a:ext uri="{FF2B5EF4-FFF2-40B4-BE49-F238E27FC236}">
-                <a16:creationId xmlns="" xmlns:a16="http://schemas.microsoft.com/office/drawing/2014/main" id="{DC2D7F71-F270-20BE-F436-A928E208D638}"/>
+                <a16:creationId xmlns:a16="http://schemas.microsoft.com/office/drawing/2014/main" xmlns="" id="{DC2D7F71-F270-20BE-F436-A928E208D638}"/>
               </a:ext>
             </a:extLst>
           </p:cNvPr>
@@ -2231,7 +2232,7 @@
           <p:cNvPr id="3" name="Content Placeholder 2">
             <a:extLst>
               <a:ext uri="{FF2B5EF4-FFF2-40B4-BE49-F238E27FC236}">
-                <a16:creationId xmlns="" xmlns:a16="http://schemas.microsoft.com/office/drawing/2014/main" id="{A499B6E9-2ECB-43DB-A2B7-8E7023717CB0}"/>
+                <a16:creationId xmlns:a16="http://schemas.microsoft.com/office/drawing/2014/main" xmlns="" id="{A499B6E9-2ECB-43DB-A2B7-8E7023717CB0}"/>
               </a:ext>
             </a:extLst>
           </p:cNvPr>
@@ -2322,7 +2323,7 @@
           <p:cNvPr id="4" name="Text Placeholder 3">
             <a:extLst>
               <a:ext uri="{FF2B5EF4-FFF2-40B4-BE49-F238E27FC236}">
-                <a16:creationId xmlns="" xmlns:a16="http://schemas.microsoft.com/office/drawing/2014/main" id="{B2943DBE-92A8-B7F9-B785-D155EA34806C}"/>
+                <a16:creationId xmlns:a16="http://schemas.microsoft.com/office/drawing/2014/main" xmlns="" id="{B2943DBE-92A8-B7F9-B785-D155EA34806C}"/>
               </a:ext>
             </a:extLst>
           </p:cNvPr>
@@ -2393,7 +2394,7 @@
           <p:cNvPr id="5" name="Date Placeholder 4">
             <a:extLst>
               <a:ext uri="{FF2B5EF4-FFF2-40B4-BE49-F238E27FC236}">
-                <a16:creationId xmlns="" xmlns:a16="http://schemas.microsoft.com/office/drawing/2014/main" id="{9E339FC9-3E6E-78FC-6FAA-AAAC0965647D}"/>
+                <a16:creationId xmlns:a16="http://schemas.microsoft.com/office/drawing/2014/main" xmlns="" id="{9E339FC9-3E6E-78FC-6FAA-AAAC0965647D}"/>
               </a:ext>
             </a:extLst>
           </p:cNvPr>
@@ -2411,7 +2412,7 @@
           <a:p>
             <a:fld id="{645F78BF-CFA7-4921-A841-16C011F814A2}" type="datetimeFigureOut">
               <a:rPr lang="en-IN" smtClean="0"/>
-              <a:t>09-04-2025</a:t>
+              <a:t>02-04-2026</a:t>
             </a:fld>
             <a:endParaRPr lang="en-IN"/>
           </a:p>
@@ -2422,7 +2423,7 @@
           <p:cNvPr id="6" name="Footer Placeholder 5">
             <a:extLst>
               <a:ext uri="{FF2B5EF4-FFF2-40B4-BE49-F238E27FC236}">
-                <a16:creationId xmlns="" xmlns:a16="http://schemas.microsoft.com/office/drawing/2014/main" id="{C646627E-E776-0E46-DEA5-5F0D360FECA5}"/>
+                <a16:creationId xmlns:a16="http://schemas.microsoft.com/office/drawing/2014/main" xmlns="" id="{C646627E-E776-0E46-DEA5-5F0D360FECA5}"/>
               </a:ext>
             </a:extLst>
           </p:cNvPr>
@@ -2447,7 +2448,7 @@
           <p:cNvPr id="7" name="Slide Number Placeholder 6">
             <a:extLst>
               <a:ext uri="{FF2B5EF4-FFF2-40B4-BE49-F238E27FC236}">
-                <a16:creationId xmlns="" xmlns:a16="http://schemas.microsoft.com/office/drawing/2014/main" id="{6F05AFFE-1913-3C8A-EFFB-4D78F52A9FAC}"/>
+                <a16:creationId xmlns:a16="http://schemas.microsoft.com/office/drawing/2014/main" xmlns="" id="{6F05AFFE-1913-3C8A-EFFB-4D78F52A9FAC}"/>
               </a:ext>
             </a:extLst>
           </p:cNvPr>
@@ -2506,7 +2507,7 @@
           <p:cNvPr id="2" name="Title 1">
             <a:extLst>
               <a:ext uri="{FF2B5EF4-FFF2-40B4-BE49-F238E27FC236}">
-                <a16:creationId xmlns="" xmlns:a16="http://schemas.microsoft.com/office/drawing/2014/main" id="{34822257-E9F7-B5C6-2F39-2094C4877F73}"/>
+                <a16:creationId xmlns:a16="http://schemas.microsoft.com/office/drawing/2014/main" xmlns="" id="{34822257-E9F7-B5C6-2F39-2094C4877F73}"/>
               </a:ext>
             </a:extLst>
           </p:cNvPr>
@@ -2544,7 +2545,7 @@
           <p:cNvPr id="3" name="Picture Placeholder 2">
             <a:extLst>
               <a:ext uri="{FF2B5EF4-FFF2-40B4-BE49-F238E27FC236}">
-                <a16:creationId xmlns="" xmlns:a16="http://schemas.microsoft.com/office/drawing/2014/main" id="{2D54FD3C-A2E0-4AC3-E2A6-83A44330746F}"/>
+                <a16:creationId xmlns:a16="http://schemas.microsoft.com/office/drawing/2014/main" xmlns="" id="{2D54FD3C-A2E0-4AC3-E2A6-83A44330746F}"/>
               </a:ext>
             </a:extLst>
           </p:cNvPr>
@@ -2611,7 +2612,7 @@
           <p:cNvPr id="4" name="Text Placeholder 3">
             <a:extLst>
               <a:ext uri="{FF2B5EF4-FFF2-40B4-BE49-F238E27FC236}">
-                <a16:creationId xmlns="" xmlns:a16="http://schemas.microsoft.com/office/drawing/2014/main" id="{B8A58BB3-9540-5FAE-4A69-42E499D7D352}"/>
+                <a16:creationId xmlns:a16="http://schemas.microsoft.com/office/drawing/2014/main" xmlns="" id="{B8A58BB3-9540-5FAE-4A69-42E499D7D352}"/>
               </a:ext>
             </a:extLst>
           </p:cNvPr>
@@ -2682,7 +2683,7 @@
           <p:cNvPr id="5" name="Date Placeholder 4">
             <a:extLst>
               <a:ext uri="{FF2B5EF4-FFF2-40B4-BE49-F238E27FC236}">
-                <a16:creationId xmlns="" xmlns:a16="http://schemas.microsoft.com/office/drawing/2014/main" id="{2C23D0A7-B929-EE8A-6874-7A8CBD0EC370}"/>
+                <a16:creationId xmlns:a16="http://schemas.microsoft.com/office/drawing/2014/main" xmlns="" id="{2C23D0A7-B929-EE8A-6874-7A8CBD0EC370}"/>
               </a:ext>
             </a:extLst>
           </p:cNvPr>
@@ -2700,7 +2701,7 @@
           <a:p>
             <a:fld id="{645F78BF-CFA7-4921-A841-16C011F814A2}" type="datetimeFigureOut">
               <a:rPr lang="en-IN" smtClean="0"/>
-              <a:t>09-04-2025</a:t>
+              <a:t>02-04-2026</a:t>
             </a:fld>
             <a:endParaRPr lang="en-IN"/>
           </a:p>
@@ -2711,7 +2712,7 @@
           <p:cNvPr id="6" name="Footer Placeholder 5">
             <a:extLst>
               <a:ext uri="{FF2B5EF4-FFF2-40B4-BE49-F238E27FC236}">
-                <a16:creationId xmlns="" xmlns:a16="http://schemas.microsoft.com/office/drawing/2014/main" id="{C0371A41-E13F-77B8-6432-35B8EEF5A26D}"/>
+                <a16:creationId xmlns:a16="http://schemas.microsoft.com/office/drawing/2014/main" xmlns="" id="{C0371A41-E13F-77B8-6432-35B8EEF5A26D}"/>
               </a:ext>
             </a:extLst>
           </p:cNvPr>
@@ -2736,7 +2737,7 @@
           <p:cNvPr id="7" name="Slide Number Placeholder 6">
             <a:extLst>
               <a:ext uri="{FF2B5EF4-FFF2-40B4-BE49-F238E27FC236}">
-                <a16:creationId xmlns="" xmlns:a16="http://schemas.microsoft.com/office/drawing/2014/main" id="{E1A8445F-3DF3-5528-90A7-2DC79EEF27E7}"/>
+                <a16:creationId xmlns:a16="http://schemas.microsoft.com/office/drawing/2014/main" xmlns="" id="{E1A8445F-3DF3-5528-90A7-2DC79EEF27E7}"/>
               </a:ext>
             </a:extLst>
           </p:cNvPr>
@@ -2800,7 +2801,7 @@
           <p:cNvPr id="2" name="Title Placeholder 1">
             <a:extLst>
               <a:ext uri="{FF2B5EF4-FFF2-40B4-BE49-F238E27FC236}">
-                <a16:creationId xmlns="" xmlns:a16="http://schemas.microsoft.com/office/drawing/2014/main" id="{18819255-2F58-9E14-8653-E0C7E4C93C1D}"/>
+                <a16:creationId xmlns:a16="http://schemas.microsoft.com/office/drawing/2014/main" xmlns="" id="{18819255-2F58-9E14-8653-E0C7E4C93C1D}"/>
               </a:ext>
             </a:extLst>
           </p:cNvPr>
@@ -2839,7 +2840,7 @@
           <p:cNvPr id="3" name="Text Placeholder 2">
             <a:extLst>
               <a:ext uri="{FF2B5EF4-FFF2-40B4-BE49-F238E27FC236}">
-                <a16:creationId xmlns="" xmlns:a16="http://schemas.microsoft.com/office/drawing/2014/main" id="{E70E9C05-4280-1CF4-5C2C-C07BB20DC79D}"/>
+                <a16:creationId xmlns:a16="http://schemas.microsoft.com/office/drawing/2014/main" xmlns="" id="{E70E9C05-4280-1CF4-5C2C-C07BB20DC79D}"/>
               </a:ext>
             </a:extLst>
           </p:cNvPr>
@@ -2907,7 +2908,7 @@
           <p:cNvPr id="4" name="Date Placeholder 3">
             <a:extLst>
               <a:ext uri="{FF2B5EF4-FFF2-40B4-BE49-F238E27FC236}">
-                <a16:creationId xmlns="" xmlns:a16="http://schemas.microsoft.com/office/drawing/2014/main" id="{19BDD5CA-40C7-CFE5-1CA6-900318EB8B07}"/>
+                <a16:creationId xmlns:a16="http://schemas.microsoft.com/office/drawing/2014/main" xmlns="" id="{19BDD5CA-40C7-CFE5-1CA6-900318EB8B07}"/>
               </a:ext>
             </a:extLst>
           </p:cNvPr>
@@ -2943,7 +2944,7 @@
           <a:p>
             <a:fld id="{645F78BF-CFA7-4921-A841-16C011F814A2}" type="datetimeFigureOut">
               <a:rPr lang="en-IN" smtClean="0"/>
-              <a:t>09-04-2025</a:t>
+              <a:t>02-04-2026</a:t>
             </a:fld>
             <a:endParaRPr lang="en-IN"/>
           </a:p>
@@ -2954,7 +2955,7 @@
           <p:cNvPr id="5" name="Footer Placeholder 4">
             <a:extLst>
               <a:ext uri="{FF2B5EF4-FFF2-40B4-BE49-F238E27FC236}">
-                <a16:creationId xmlns="" xmlns:a16="http://schemas.microsoft.com/office/drawing/2014/main" id="{0D3B7131-27E0-DED8-AB33-3FD9D479C1AF}"/>
+                <a16:creationId xmlns:a16="http://schemas.microsoft.com/office/drawing/2014/main" xmlns="" id="{0D3B7131-27E0-DED8-AB33-3FD9D479C1AF}"/>
               </a:ext>
             </a:extLst>
           </p:cNvPr>
@@ -2997,7 +2998,7 @@
           <p:cNvPr id="6" name="Slide Number Placeholder 5">
             <a:extLst>
               <a:ext uri="{FF2B5EF4-FFF2-40B4-BE49-F238E27FC236}">
-                <a16:creationId xmlns="" xmlns:a16="http://schemas.microsoft.com/office/drawing/2014/main" id="{1D741E3D-62C1-7F64-B293-CED977D54D9E}"/>
+                <a16:creationId xmlns:a16="http://schemas.microsoft.com/office/drawing/2014/main" xmlns="" id="{1D741E3D-62C1-7F64-B293-CED977D54D9E}"/>
               </a:ext>
             </a:extLst>
           </p:cNvPr>
@@ -3365,7 +3366,7 @@
           <p:cNvPr id="2" name="Title 1">
             <a:extLst>
               <a:ext uri="{FF2B5EF4-FFF2-40B4-BE49-F238E27FC236}">
-                <a16:creationId xmlns="" xmlns:a16="http://schemas.microsoft.com/office/drawing/2014/main" id="{DFA44487-CF5A-0FC7-63D5-8F207F88C3E6}"/>
+                <a16:creationId xmlns:a16="http://schemas.microsoft.com/office/drawing/2014/main" xmlns="" id="{DFA44487-CF5A-0FC7-63D5-8F207F88C3E6}"/>
               </a:ext>
             </a:extLst>
           </p:cNvPr>
@@ -3393,7 +3394,7 @@
           <p:cNvPr id="3" name="Subtitle 2">
             <a:extLst>
               <a:ext uri="{FF2B5EF4-FFF2-40B4-BE49-F238E27FC236}">
-                <a16:creationId xmlns="" xmlns:a16="http://schemas.microsoft.com/office/drawing/2014/main" id="{559FFCEA-A9C0-F6CC-84F0-72942AC0AA1E}"/>
+                <a16:creationId xmlns:a16="http://schemas.microsoft.com/office/drawing/2014/main" xmlns="" id="{559FFCEA-A9C0-F6CC-84F0-72942AC0AA1E}"/>
               </a:ext>
             </a:extLst>
           </p:cNvPr>
@@ -3463,6 +3464,850 @@
             <p:ph type="title"/>
           </p:nvPr>
         </p:nvSpPr>
+        <p:spPr>
+          <a:xfrm>
+            <a:off x="479685" y="140212"/>
+            <a:ext cx="11422505" cy="1325563"/>
+          </a:xfrm>
+        </p:spPr>
+        <p:txBody>
+          <a:bodyPr/>
+          <a:lstStyle/>
+          <a:p>
+            <a:r>
+              <a:rPr lang="en-US" dirty="0" smtClean="0"/>
+              <a:t>Merge(),  Join() and </a:t>
+            </a:r>
+            <a:r>
+              <a:rPr lang="en-US" dirty="0" err="1" smtClean="0"/>
+              <a:t>Concat</a:t>
+            </a:r>
+            <a:r>
+              <a:rPr lang="en-US" dirty="0" smtClean="0"/>
+              <a:t>() </a:t>
+            </a:r>
+            <a:r>
+              <a:rPr lang="en-US" dirty="0" err="1" smtClean="0"/>
+              <a:t>Dataframe</a:t>
+            </a:r>
+            <a:endParaRPr lang="en-IN" dirty="0"/>
+          </a:p>
+        </p:txBody>
+      </p:sp>
+      <p:graphicFrame>
+        <p:nvGraphicFramePr>
+          <p:cNvPr id="4" name="Content Placeholder 3"/>
+          <p:cNvGraphicFramePr>
+            <a:graphicFrameLocks noGrp="1"/>
+          </p:cNvGraphicFramePr>
+          <p:nvPr>
+            <p:ph idx="1"/>
+            <p:extLst>
+              <p:ext uri="{D42A27DB-BD31-4B8C-83A1-F6EECF244321}">
+                <p14:modId xmlns:p14="http://schemas.microsoft.com/office/powerpoint/2010/main" val="1161266127"/>
+              </p:ext>
+            </p:extLst>
+          </p:nvPr>
+        </p:nvGraphicFramePr>
+        <p:xfrm>
+          <a:off x="599608" y="2401093"/>
+          <a:ext cx="11302584" cy="4089649"/>
+        </p:xfrm>
+        <a:graphic>
+          <a:graphicData uri="http://schemas.openxmlformats.org/drawingml/2006/table">
+            <a:tbl>
+              <a:tblPr/>
+              <a:tblGrid>
+                <a:gridCol w="1873769"/>
+                <a:gridCol w="3507698"/>
+                <a:gridCol w="3095471"/>
+                <a:gridCol w="2825646"/>
+              </a:tblGrid>
+              <a:tr h="467389">
+                <a:tc>
+                  <a:txBody>
+                    <a:bodyPr/>
+                    <a:lstStyle/>
+                    <a:p>
+                      <a:r>
+                        <a:rPr lang="en-IN" b="1" dirty="0">
+                          <a:latin typeface="Times New Roman" panose="02020603050405020304" pitchFamily="18" charset="0"/>
+                          <a:cs typeface="Times New Roman" panose="02020603050405020304" pitchFamily="18" charset="0"/>
+                        </a:rPr>
+                        <a:t>Feature</a:t>
+                      </a:r>
+                    </a:p>
+                  </a:txBody>
+                  <a:tcPr anchor="ctr">
+                    <a:lnL>
+                      <a:noFill/>
+                    </a:lnL>
+                    <a:lnR>
+                      <a:noFill/>
+                    </a:lnR>
+                    <a:lnT>
+                      <a:noFill/>
+                    </a:lnT>
+                    <a:lnB>
+                      <a:noFill/>
+                    </a:lnB>
+                  </a:tcPr>
+                </a:tc>
+                <a:tc>
+                  <a:txBody>
+                    <a:bodyPr/>
+                    <a:lstStyle/>
+                    <a:p>
+                      <a:r>
+                        <a:rPr lang="en-IN" b="1" dirty="0">
+                          <a:latin typeface="Times New Roman" panose="02020603050405020304" pitchFamily="18" charset="0"/>
+                          <a:cs typeface="Times New Roman" panose="02020603050405020304" pitchFamily="18" charset="0"/>
+                        </a:rPr>
+                        <a:t>merge()</a:t>
+                      </a:r>
+                    </a:p>
+                  </a:txBody>
+                  <a:tcPr anchor="ctr">
+                    <a:lnL>
+                      <a:noFill/>
+                    </a:lnL>
+                    <a:lnR>
+                      <a:noFill/>
+                    </a:lnR>
+                    <a:lnT>
+                      <a:noFill/>
+                    </a:lnT>
+                    <a:lnB>
+                      <a:noFill/>
+                    </a:lnB>
+                  </a:tcPr>
+                </a:tc>
+                <a:tc>
+                  <a:txBody>
+                    <a:bodyPr/>
+                    <a:lstStyle/>
+                    <a:p>
+                      <a:r>
+                        <a:rPr lang="en-IN" b="1" dirty="0" err="1">
+                          <a:latin typeface="Times New Roman" panose="02020603050405020304" pitchFamily="18" charset="0"/>
+                          <a:cs typeface="Times New Roman" panose="02020603050405020304" pitchFamily="18" charset="0"/>
+                        </a:rPr>
+                        <a:t>concat</a:t>
+                      </a:r>
+                      <a:r>
+                        <a:rPr lang="en-IN" b="1" dirty="0">
+                          <a:latin typeface="Times New Roman" panose="02020603050405020304" pitchFamily="18" charset="0"/>
+                          <a:cs typeface="Times New Roman" panose="02020603050405020304" pitchFamily="18" charset="0"/>
+                        </a:rPr>
+                        <a:t>()</a:t>
+                      </a:r>
+                    </a:p>
+                  </a:txBody>
+                  <a:tcPr anchor="ctr">
+                    <a:lnL>
+                      <a:noFill/>
+                    </a:lnL>
+                    <a:lnR>
+                      <a:noFill/>
+                    </a:lnR>
+                    <a:lnT>
+                      <a:noFill/>
+                    </a:lnT>
+                    <a:lnB>
+                      <a:noFill/>
+                    </a:lnB>
+                  </a:tcPr>
+                </a:tc>
+                <a:tc>
+                  <a:txBody>
+                    <a:bodyPr/>
+                    <a:lstStyle/>
+                    <a:p>
+                      <a:r>
+                        <a:rPr lang="en-IN" b="1" dirty="0">
+                          <a:latin typeface="Times New Roman" panose="02020603050405020304" pitchFamily="18" charset="0"/>
+                          <a:cs typeface="Times New Roman" panose="02020603050405020304" pitchFamily="18" charset="0"/>
+                        </a:rPr>
+                        <a:t>join()</a:t>
+                      </a:r>
+                    </a:p>
+                  </a:txBody>
+                  <a:tcPr anchor="ctr">
+                    <a:lnL>
+                      <a:noFill/>
+                    </a:lnL>
+                    <a:lnR>
+                      <a:noFill/>
+                    </a:lnR>
+                    <a:lnT>
+                      <a:noFill/>
+                    </a:lnT>
+                    <a:lnB>
+                      <a:noFill/>
+                    </a:lnB>
+                  </a:tcPr>
+                </a:tc>
+              </a:tr>
+              <a:tr h="817930">
+                <a:tc>
+                  <a:txBody>
+                    <a:bodyPr/>
+                    <a:lstStyle/>
+                    <a:p>
+                      <a:r>
+                        <a:rPr lang="en-IN" dirty="0">
+                          <a:latin typeface="Times New Roman" panose="02020603050405020304" pitchFamily="18" charset="0"/>
+                          <a:cs typeface="Times New Roman" panose="02020603050405020304" pitchFamily="18" charset="0"/>
+                        </a:rPr>
+                        <a:t>Based On</a:t>
+                      </a:r>
+                    </a:p>
+                  </a:txBody>
+                  <a:tcPr anchor="ctr">
+                    <a:lnL>
+                      <a:noFill/>
+                    </a:lnL>
+                    <a:lnR>
+                      <a:noFill/>
+                    </a:lnR>
+                    <a:lnT>
+                      <a:noFill/>
+                    </a:lnT>
+                    <a:lnB>
+                      <a:noFill/>
+                    </a:lnB>
+                  </a:tcPr>
+                </a:tc>
+                <a:tc>
+                  <a:txBody>
+                    <a:bodyPr/>
+                    <a:lstStyle/>
+                    <a:p>
+                      <a:r>
+                        <a:rPr lang="en-IN">
+                          <a:latin typeface="Times New Roman" panose="02020603050405020304" pitchFamily="18" charset="0"/>
+                          <a:cs typeface="Times New Roman" panose="02020603050405020304" pitchFamily="18" charset="0"/>
+                        </a:rPr>
+                        <a:t>Columns (keys)</a:t>
+                      </a:r>
+                    </a:p>
+                  </a:txBody>
+                  <a:tcPr anchor="ctr">
+                    <a:lnL>
+                      <a:noFill/>
+                    </a:lnL>
+                    <a:lnR>
+                      <a:noFill/>
+                    </a:lnR>
+                    <a:lnT>
+                      <a:noFill/>
+                    </a:lnT>
+                    <a:lnB>
+                      <a:noFill/>
+                    </a:lnB>
+                  </a:tcPr>
+                </a:tc>
+                <a:tc>
+                  <a:txBody>
+                    <a:bodyPr/>
+                    <a:lstStyle/>
+                    <a:p>
+                      <a:r>
+                        <a:rPr lang="en-IN" dirty="0">
+                          <a:latin typeface="Times New Roman" panose="02020603050405020304" pitchFamily="18" charset="0"/>
+                          <a:cs typeface="Times New Roman" panose="02020603050405020304" pitchFamily="18" charset="0"/>
+                        </a:rPr>
+                        <a:t>Axis (rows or columns)</a:t>
+                      </a:r>
+                    </a:p>
+                  </a:txBody>
+                  <a:tcPr anchor="ctr">
+                    <a:lnL>
+                      <a:noFill/>
+                    </a:lnL>
+                    <a:lnR>
+                      <a:noFill/>
+                    </a:lnR>
+                    <a:lnT>
+                      <a:noFill/>
+                    </a:lnT>
+                    <a:lnB>
+                      <a:noFill/>
+                    </a:lnB>
+                  </a:tcPr>
+                </a:tc>
+                <a:tc>
+                  <a:txBody>
+                    <a:bodyPr/>
+                    <a:lstStyle/>
+                    <a:p>
+                      <a:r>
+                        <a:rPr lang="en-US">
+                          <a:latin typeface="Times New Roman" panose="02020603050405020304" pitchFamily="18" charset="0"/>
+                          <a:cs typeface="Times New Roman" panose="02020603050405020304" pitchFamily="18" charset="0"/>
+                        </a:rPr>
+                        <a:t>Index (by default) or key column</a:t>
+                      </a:r>
+                    </a:p>
+                  </a:txBody>
+                  <a:tcPr anchor="ctr">
+                    <a:lnL>
+                      <a:noFill/>
+                    </a:lnL>
+                    <a:lnR>
+                      <a:noFill/>
+                    </a:lnR>
+                    <a:lnT>
+                      <a:noFill/>
+                    </a:lnT>
+                    <a:lnB>
+                      <a:noFill/>
+                    </a:lnB>
+                  </a:tcPr>
+                </a:tc>
+              </a:tr>
+              <a:tr h="817930">
+                <a:tc>
+                  <a:txBody>
+                    <a:bodyPr/>
+                    <a:lstStyle/>
+                    <a:p>
+                      <a:r>
+                        <a:rPr lang="en-IN">
+                          <a:latin typeface="Times New Roman" panose="02020603050405020304" pitchFamily="18" charset="0"/>
+                          <a:cs typeface="Times New Roman" panose="02020603050405020304" pitchFamily="18" charset="0"/>
+                        </a:rPr>
+                        <a:t>Similar To</a:t>
+                      </a:r>
+                    </a:p>
+                  </a:txBody>
+                  <a:tcPr anchor="ctr">
+                    <a:lnL>
+                      <a:noFill/>
+                    </a:lnL>
+                    <a:lnR>
+                      <a:noFill/>
+                    </a:lnR>
+                    <a:lnT>
+                      <a:noFill/>
+                    </a:lnT>
+                    <a:lnB>
+                      <a:noFill/>
+                    </a:lnB>
+                  </a:tcPr>
+                </a:tc>
+                <a:tc>
+                  <a:txBody>
+                    <a:bodyPr/>
+                    <a:lstStyle/>
+                    <a:p>
+                      <a:r>
+                        <a:rPr lang="en-IN">
+                          <a:latin typeface="Times New Roman" panose="02020603050405020304" pitchFamily="18" charset="0"/>
+                          <a:cs typeface="Times New Roman" panose="02020603050405020304" pitchFamily="18" charset="0"/>
+                        </a:rPr>
+                        <a:t>SQL JOIN</a:t>
+                      </a:r>
+                    </a:p>
+                  </a:txBody>
+                  <a:tcPr anchor="ctr">
+                    <a:lnL>
+                      <a:noFill/>
+                    </a:lnL>
+                    <a:lnR>
+                      <a:noFill/>
+                    </a:lnR>
+                    <a:lnT>
+                      <a:noFill/>
+                    </a:lnT>
+                    <a:lnB>
+                      <a:noFill/>
+                    </a:lnB>
+                  </a:tcPr>
+                </a:tc>
+                <a:tc>
+                  <a:txBody>
+                    <a:bodyPr/>
+                    <a:lstStyle/>
+                    <a:p>
+                      <a:r>
+                        <a:rPr lang="en-IN" dirty="0">
+                          <a:latin typeface="Times New Roman" panose="02020603050405020304" pitchFamily="18" charset="0"/>
+                          <a:cs typeface="Times New Roman" panose="02020603050405020304" pitchFamily="18" charset="0"/>
+                        </a:rPr>
+                        <a:t>Stacking (</a:t>
+                      </a:r>
+                      <a:r>
+                        <a:rPr lang="en-IN" dirty="0" smtClean="0">
+                          <a:latin typeface="Times New Roman" panose="02020603050405020304" pitchFamily="18" charset="0"/>
+                          <a:cs typeface="Times New Roman" panose="02020603050405020304" pitchFamily="18" charset="0"/>
+                        </a:rPr>
+                        <a:t>vertical=0 </a:t>
+                      </a:r>
+                      <a:r>
+                        <a:rPr lang="en-IN" dirty="0">
+                          <a:latin typeface="Times New Roman" panose="02020603050405020304" pitchFamily="18" charset="0"/>
+                          <a:cs typeface="Times New Roman" panose="02020603050405020304" pitchFamily="18" charset="0"/>
+                        </a:rPr>
+                        <a:t>or </a:t>
+                      </a:r>
+                      <a:r>
+                        <a:rPr lang="en-IN" dirty="0" smtClean="0">
+                          <a:latin typeface="Times New Roman" panose="02020603050405020304" pitchFamily="18" charset="0"/>
+                          <a:cs typeface="Times New Roman" panose="02020603050405020304" pitchFamily="18" charset="0"/>
+                        </a:rPr>
+                        <a:t>horizontal=1) using axis</a:t>
+                      </a:r>
+                      <a:endParaRPr lang="en-IN" dirty="0">
+                        <a:latin typeface="Times New Roman" panose="02020603050405020304" pitchFamily="18" charset="0"/>
+                        <a:cs typeface="Times New Roman" panose="02020603050405020304" pitchFamily="18" charset="0"/>
+                      </a:endParaRPr>
+                    </a:p>
+                  </a:txBody>
+                  <a:tcPr anchor="ctr">
+                    <a:lnL>
+                      <a:noFill/>
+                    </a:lnL>
+                    <a:lnR>
+                      <a:noFill/>
+                    </a:lnR>
+                    <a:lnT>
+                      <a:noFill/>
+                    </a:lnT>
+                    <a:lnB>
+                      <a:noFill/>
+                    </a:lnB>
+                  </a:tcPr>
+                </a:tc>
+                <a:tc>
+                  <a:txBody>
+                    <a:bodyPr/>
+                    <a:lstStyle/>
+                    <a:p>
+                      <a:r>
+                        <a:rPr lang="en-IN">
+                          <a:latin typeface="Times New Roman" panose="02020603050405020304" pitchFamily="18" charset="0"/>
+                          <a:cs typeface="Times New Roman" panose="02020603050405020304" pitchFamily="18" charset="0"/>
+                        </a:rPr>
+                        <a:t>SQL JOIN on index</a:t>
+                      </a:r>
+                    </a:p>
+                  </a:txBody>
+                  <a:tcPr anchor="ctr">
+                    <a:lnL>
+                      <a:noFill/>
+                    </a:lnL>
+                    <a:lnR>
+                      <a:noFill/>
+                    </a:lnR>
+                    <a:lnT>
+                      <a:noFill/>
+                    </a:lnT>
+                    <a:lnB>
+                      <a:noFill/>
+                    </a:lnB>
+                  </a:tcPr>
+                </a:tc>
+              </a:tr>
+              <a:tr h="817930">
+                <a:tc>
+                  <a:txBody>
+                    <a:bodyPr/>
+                    <a:lstStyle/>
+                    <a:p>
+                      <a:r>
+                        <a:rPr lang="en-IN">
+                          <a:latin typeface="Times New Roman" panose="02020603050405020304" pitchFamily="18" charset="0"/>
+                          <a:cs typeface="Times New Roman" panose="02020603050405020304" pitchFamily="18" charset="0"/>
+                        </a:rPr>
+                        <a:t>Best Use</a:t>
+                      </a:r>
+                    </a:p>
+                  </a:txBody>
+                  <a:tcPr anchor="ctr">
+                    <a:lnL>
+                      <a:noFill/>
+                    </a:lnL>
+                    <a:lnR>
+                      <a:noFill/>
+                    </a:lnR>
+                    <a:lnT>
+                      <a:noFill/>
+                    </a:lnT>
+                    <a:lnB>
+                      <a:noFill/>
+                    </a:lnB>
+                  </a:tcPr>
+                </a:tc>
+                <a:tc>
+                  <a:txBody>
+                    <a:bodyPr/>
+                    <a:lstStyle/>
+                    <a:p>
+                      <a:r>
+                        <a:rPr lang="en-US">
+                          <a:latin typeface="Times New Roman" panose="02020603050405020304" pitchFamily="18" charset="0"/>
+                          <a:cs typeface="Times New Roman" panose="02020603050405020304" pitchFamily="18" charset="0"/>
+                        </a:rPr>
+                        <a:t>Combining related tables via keys</a:t>
+                      </a:r>
+                    </a:p>
+                  </a:txBody>
+                  <a:tcPr anchor="ctr">
+                    <a:lnL>
+                      <a:noFill/>
+                    </a:lnL>
+                    <a:lnR>
+                      <a:noFill/>
+                    </a:lnR>
+                    <a:lnT>
+                      <a:noFill/>
+                    </a:lnT>
+                    <a:lnB>
+                      <a:noFill/>
+                    </a:lnB>
+                  </a:tcPr>
+                </a:tc>
+                <a:tc>
+                  <a:txBody>
+                    <a:bodyPr/>
+                    <a:lstStyle/>
+                    <a:p>
+                      <a:r>
+                        <a:rPr lang="en-IN">
+                          <a:latin typeface="Times New Roman" panose="02020603050405020304" pitchFamily="18" charset="0"/>
+                          <a:cs typeface="Times New Roman" panose="02020603050405020304" pitchFamily="18" charset="0"/>
+                        </a:rPr>
+                        <a:t>Appending similar datasets</a:t>
+                      </a:r>
+                    </a:p>
+                  </a:txBody>
+                  <a:tcPr anchor="ctr">
+                    <a:lnL>
+                      <a:noFill/>
+                    </a:lnL>
+                    <a:lnR>
+                      <a:noFill/>
+                    </a:lnR>
+                    <a:lnT>
+                      <a:noFill/>
+                    </a:lnT>
+                    <a:lnB>
+                      <a:noFill/>
+                    </a:lnB>
+                  </a:tcPr>
+                </a:tc>
+                <a:tc>
+                  <a:txBody>
+                    <a:bodyPr/>
+                    <a:lstStyle/>
+                    <a:p>
+                      <a:r>
+                        <a:rPr lang="en-IN">
+                          <a:latin typeface="Times New Roman" panose="02020603050405020304" pitchFamily="18" charset="0"/>
+                          <a:cs typeface="Times New Roman" panose="02020603050405020304" pitchFamily="18" charset="0"/>
+                        </a:rPr>
+                        <a:t>Joining on index (simple)</a:t>
+                      </a:r>
+                    </a:p>
+                  </a:txBody>
+                  <a:tcPr anchor="ctr">
+                    <a:lnL>
+                      <a:noFill/>
+                    </a:lnL>
+                    <a:lnR>
+                      <a:noFill/>
+                    </a:lnR>
+                    <a:lnT>
+                      <a:noFill/>
+                    </a:lnT>
+                    <a:lnB>
+                      <a:noFill/>
+                    </a:lnB>
+                  </a:tcPr>
+                </a:tc>
+              </a:tr>
+              <a:tr h="1168470">
+                <a:tc>
+                  <a:txBody>
+                    <a:bodyPr/>
+                    <a:lstStyle/>
+                    <a:p>
+                      <a:r>
+                        <a:rPr lang="en-IN" dirty="0">
+                          <a:latin typeface="Times New Roman" panose="02020603050405020304" pitchFamily="18" charset="0"/>
+                          <a:cs typeface="Times New Roman" panose="02020603050405020304" pitchFamily="18" charset="0"/>
+                        </a:rPr>
+                        <a:t>Flexibility</a:t>
+                      </a:r>
+                    </a:p>
+                  </a:txBody>
+                  <a:tcPr anchor="ctr">
+                    <a:lnL>
+                      <a:noFill/>
+                    </a:lnL>
+                    <a:lnR>
+                      <a:noFill/>
+                    </a:lnR>
+                    <a:lnT>
+                      <a:noFill/>
+                    </a:lnT>
+                    <a:lnB>
+                      <a:noFill/>
+                    </a:lnB>
+                  </a:tcPr>
+                </a:tc>
+                <a:tc>
+                  <a:txBody>
+                    <a:bodyPr/>
+                    <a:lstStyle/>
+                    <a:p>
+                      <a:r>
+                        <a:rPr lang="en-US">
+                          <a:latin typeface="Times New Roman" panose="02020603050405020304" pitchFamily="18" charset="0"/>
+                          <a:cs typeface="Times New Roman" panose="02020603050405020304" pitchFamily="18" charset="0"/>
+                        </a:rPr>
+                        <a:t>High – allows custom join types (inner, outer, left, right)</a:t>
+                      </a:r>
+                    </a:p>
+                  </a:txBody>
+                  <a:tcPr anchor="ctr">
+                    <a:lnL>
+                      <a:noFill/>
+                    </a:lnL>
+                    <a:lnR>
+                      <a:noFill/>
+                    </a:lnR>
+                    <a:lnT>
+                      <a:noFill/>
+                    </a:lnT>
+                    <a:lnB>
+                      <a:noFill/>
+                    </a:lnB>
+                  </a:tcPr>
+                </a:tc>
+                <a:tc>
+                  <a:txBody>
+                    <a:bodyPr/>
+                    <a:lstStyle/>
+                    <a:p>
+                      <a:r>
+                        <a:rPr lang="en-IN">
+                          <a:latin typeface="Times New Roman" panose="02020603050405020304" pitchFamily="18" charset="0"/>
+                          <a:cs typeface="Times New Roman" panose="02020603050405020304" pitchFamily="18" charset="0"/>
+                        </a:rPr>
+                        <a:t>Medium</a:t>
+                      </a:r>
+                    </a:p>
+                  </a:txBody>
+                  <a:tcPr anchor="ctr">
+                    <a:lnL>
+                      <a:noFill/>
+                    </a:lnL>
+                    <a:lnR>
+                      <a:noFill/>
+                    </a:lnR>
+                    <a:lnT>
+                      <a:noFill/>
+                    </a:lnT>
+                    <a:lnB>
+                      <a:noFill/>
+                    </a:lnB>
+                  </a:tcPr>
+                </a:tc>
+                <a:tc>
+                  <a:txBody>
+                    <a:bodyPr/>
+                    <a:lstStyle/>
+                    <a:p>
+                      <a:r>
+                        <a:rPr lang="en-IN" dirty="0">
+                          <a:latin typeface="Times New Roman" panose="02020603050405020304" pitchFamily="18" charset="0"/>
+                          <a:cs typeface="Times New Roman" panose="02020603050405020304" pitchFamily="18" charset="0"/>
+                        </a:rPr>
+                        <a:t>Medium</a:t>
+                      </a:r>
+                    </a:p>
+                  </a:txBody>
+                  <a:tcPr anchor="ctr">
+                    <a:lnL>
+                      <a:noFill/>
+                    </a:lnL>
+                    <a:lnR>
+                      <a:noFill/>
+                    </a:lnR>
+                    <a:lnT>
+                      <a:noFill/>
+                    </a:lnT>
+                    <a:lnB>
+                      <a:noFill/>
+                    </a:lnB>
+                  </a:tcPr>
+                </a:tc>
+              </a:tr>
+            </a:tbl>
+          </a:graphicData>
+        </a:graphic>
+      </p:graphicFrame>
+      <p:sp>
+        <p:nvSpPr>
+          <p:cNvPr id="5" name="Rectangle 1"/>
+          <p:cNvSpPr>
+            <a:spLocks noChangeArrowheads="1"/>
+          </p:cNvSpPr>
+          <p:nvPr/>
+        </p:nvSpPr>
+        <p:spPr bwMode="auto">
+          <a:xfrm>
+            <a:off x="479685" y="1465775"/>
+            <a:ext cx="2444900" cy="707886"/>
+          </a:xfrm>
+          <a:prstGeom prst="rect">
+            <a:avLst/>
+          </a:prstGeom>
+          <a:noFill/>
+          <a:ln>
+            <a:noFill/>
+          </a:ln>
+          <a:effectLst/>
+          <a:extLst>
+            <a:ext uri="{909E8E84-426E-40DD-AFC4-6F175D3DCCD1}">
+              <a14:hiddenFill xmlns:a14="http://schemas.microsoft.com/office/drawing/2010/main">
+                <a:solidFill>
+                  <a:schemeClr val="accent1"/>
+                </a:solidFill>
+              </a14:hiddenFill>
+            </a:ext>
+            <a:ext uri="{91240B29-F687-4F45-9708-019B960494DF}">
+              <a14:hiddenLine xmlns:a14="http://schemas.microsoft.com/office/drawing/2010/main" w="9525">
+                <a:solidFill>
+                  <a:schemeClr val="tx1"/>
+                </a:solidFill>
+                <a:miter lim="800000"/>
+                <a:headEnd/>
+                <a:tailEnd/>
+              </a14:hiddenLine>
+            </a:ext>
+            <a:ext uri="{AF507438-7753-43E0-B8FC-AC1667EBCBE1}">
+              <a14:hiddenEffects xmlns:a14="http://schemas.microsoft.com/office/drawing/2010/main">
+                <a:effectLst>
+                  <a:outerShdw dist="35921" dir="2700000" algn="ctr" rotWithShape="0">
+                    <a:schemeClr val="bg2"/>
+                  </a:outerShdw>
+                </a:effectLst>
+              </a14:hiddenEffects>
+            </a:ext>
+          </a:extLst>
+        </p:spPr>
+        <p:txBody>
+          <a:bodyPr vert="horz" wrap="none" lIns="91440" tIns="45720" rIns="91440" bIns="45720" numCol="1" anchor="ctr" anchorCtr="0" compatLnSpc="1">
+            <a:prstTxWarp prst="textNoShape">
+              <a:avLst/>
+            </a:prstTxWarp>
+            <a:spAutoFit/>
+          </a:bodyPr>
+          <a:lstStyle/>
+          <a:p>
+            <a:pPr marL="0" marR="0" lvl="0" indent="0" algn="l" defTabSz="914400" rtl="0" eaLnBrk="0" fontAlgn="base" latinLnBrk="0" hangingPunct="0">
+              <a:lnSpc>
+                <a:spcPct val="100000"/>
+              </a:lnSpc>
+              <a:spcBef>
+                <a:spcPct val="0"/>
+              </a:spcBef>
+              <a:spcAft>
+                <a:spcPct val="0"/>
+              </a:spcAft>
+              <a:buClrTx/>
+              <a:buSzTx/>
+              <a:buFontTx/>
+              <a:buNone/>
+              <a:tabLst/>
+            </a:pPr>
+            <a:r>
+              <a:rPr kumimoji="0" lang="en-US" sz="2200" b="1" i="0" u="none" strike="noStrike" cap="none" normalizeH="0" baseline="0" dirty="0" smtClean="0">
+                <a:ln>
+                  <a:noFill/>
+                </a:ln>
+                <a:solidFill>
+                  <a:schemeClr val="tx1"/>
+                </a:solidFill>
+                <a:effectLst/>
+                <a:latin typeface="Arial" panose="020B0604020202020204" pitchFamily="34" charset="0"/>
+              </a:rPr>
+              <a:t>Core Differences</a:t>
+            </a:r>
+          </a:p>
+          <a:p>
+            <a:pPr marL="0" marR="0" lvl="0" indent="0" algn="l" defTabSz="914400" rtl="0" eaLnBrk="0" fontAlgn="base" latinLnBrk="0" hangingPunct="0">
+              <a:lnSpc>
+                <a:spcPct val="100000"/>
+              </a:lnSpc>
+              <a:spcBef>
+                <a:spcPct val="0"/>
+              </a:spcBef>
+              <a:spcAft>
+                <a:spcPct val="0"/>
+              </a:spcAft>
+              <a:buClrTx/>
+              <a:buSzTx/>
+              <a:buFontTx/>
+              <a:buNone/>
+              <a:tabLst/>
+            </a:pPr>
+            <a:endParaRPr kumimoji="0" lang="en-US" sz="1800" b="0" i="0" u="none" strike="noStrike" cap="none" normalizeH="0" baseline="0" dirty="0" smtClean="0">
+              <a:ln>
+                <a:noFill/>
+              </a:ln>
+              <a:solidFill>
+                <a:schemeClr val="tx1"/>
+              </a:solidFill>
+              <a:effectLst/>
+              <a:latin typeface="Arial" panose="020B0604020202020204" pitchFamily="34" charset="0"/>
+            </a:endParaRPr>
+          </a:p>
+        </p:txBody>
+      </p:sp>
+    </p:spTree>
+    <p:extLst>
+      <p:ext uri="{BB962C8B-B14F-4D97-AF65-F5344CB8AC3E}">
+        <p14:creationId xmlns:p14="http://schemas.microsoft.com/office/powerpoint/2010/main" val="3729838864"/>
+      </p:ext>
+    </p:extLst>
+  </p:cSld>
+  <p:clrMapOvr>
+    <a:masterClrMapping/>
+  </p:clrMapOvr>
+</p:sld>
+</file>
+
+<file path=ppt/slides/slide11.xml><?xml version="1.0" encoding="utf-8"?>
+<p:sld xmlns:a="http://schemas.openxmlformats.org/drawingml/2006/main" xmlns:r="http://schemas.openxmlformats.org/officeDocument/2006/relationships" xmlns:p="http://schemas.openxmlformats.org/presentationml/2006/main">
+  <p:cSld>
+    <p:spTree>
+      <p:nvGrpSpPr>
+        <p:cNvPr id="1" name=""/>
+        <p:cNvGrpSpPr/>
+        <p:nvPr/>
+      </p:nvGrpSpPr>
+      <p:grpSpPr>
+        <a:xfrm>
+          <a:off x="0" y="0"/>
+          <a:ext cx="0" cy="0"/>
+          <a:chOff x="0" y="0"/>
+          <a:chExt cx="0" cy="0"/>
+        </a:xfrm>
+      </p:grpSpPr>
+      <p:sp>
+        <p:nvSpPr>
+          <p:cNvPr id="2" name="Title 1"/>
+          <p:cNvSpPr>
+            <a:spLocks noGrp="1"/>
+          </p:cNvSpPr>
+          <p:nvPr>
+            <p:ph type="title"/>
+          </p:nvPr>
+        </p:nvSpPr>
         <p:spPr/>
         <p:txBody>
           <a:bodyPr/>
@@ -3899,125 +4744,6 @@
 </p:sld>
 </file>
 
-<file path=ppt/slides/slide11.xml><?xml version="1.0" encoding="utf-8"?>
-<p:sld xmlns:a="http://schemas.openxmlformats.org/drawingml/2006/main" xmlns:r="http://schemas.openxmlformats.org/officeDocument/2006/relationships" xmlns:p="http://schemas.openxmlformats.org/presentationml/2006/main">
-  <p:cSld>
-    <p:spTree>
-      <p:nvGrpSpPr>
-        <p:cNvPr id="1" name=""/>
-        <p:cNvGrpSpPr/>
-        <p:nvPr/>
-      </p:nvGrpSpPr>
-      <p:grpSpPr>
-        <a:xfrm>
-          <a:off x="0" y="0"/>
-          <a:ext cx="0" cy="0"/>
-          <a:chOff x="0" y="0"/>
-          <a:chExt cx="0" cy="0"/>
-        </a:xfrm>
-      </p:grpSpPr>
-      <p:sp>
-        <p:nvSpPr>
-          <p:cNvPr id="2" name="Title 1"/>
-          <p:cNvSpPr>
-            <a:spLocks noGrp="1"/>
-          </p:cNvSpPr>
-          <p:nvPr>
-            <p:ph type="title"/>
-          </p:nvPr>
-        </p:nvSpPr>
-        <p:spPr/>
-        <p:txBody>
-          <a:bodyPr/>
-          <a:lstStyle/>
-          <a:p>
-            <a:r>
-              <a:rPr lang="en-US" dirty="0" err="1" smtClean="0"/>
-              <a:t>Concat</a:t>
-            </a:r>
-            <a:r>
-              <a:rPr lang="en-US" dirty="0" smtClean="0"/>
-              <a:t>()</a:t>
-            </a:r>
-            <a:endParaRPr lang="en-IN" dirty="0"/>
-          </a:p>
-        </p:txBody>
-      </p:sp>
-      <p:sp>
-        <p:nvSpPr>
-          <p:cNvPr id="3" name="Content Placeholder 2"/>
-          <p:cNvSpPr>
-            <a:spLocks noGrp="1"/>
-          </p:cNvSpPr>
-          <p:nvPr>
-            <p:ph idx="1"/>
-          </p:nvPr>
-        </p:nvSpPr>
-        <p:spPr/>
-        <p:txBody>
-          <a:bodyPr/>
-          <a:lstStyle/>
-          <a:p>
-            <a:r>
-              <a:rPr lang="en-IN" dirty="0" err="1"/>
-              <a:t>pd.concat</a:t>
-            </a:r>
-            <a:r>
-              <a:rPr lang="en-IN" dirty="0"/>
-              <a:t>(</a:t>
-            </a:r>
-            <a:r>
-              <a:rPr lang="en-IN" dirty="0" err="1"/>
-              <a:t>objs</a:t>
-            </a:r>
-            <a:r>
-              <a:rPr lang="en-IN" dirty="0"/>
-              <a:t>, axis=0, join='outer', </a:t>
-            </a:r>
-            <a:r>
-              <a:rPr lang="en-IN" dirty="0" err="1"/>
-              <a:t>ignore_index</a:t>
-            </a:r>
-            <a:r>
-              <a:rPr lang="en-IN" dirty="0"/>
-              <a:t>=False</a:t>
-            </a:r>
-            <a:r>
-              <a:rPr lang="en-IN" dirty="0" smtClean="0"/>
-              <a:t>,  </a:t>
-            </a:r>
-            <a:r>
-              <a:rPr lang="en-IN" dirty="0"/>
-              <a:t>keys=None, levels=None, names=None, </a:t>
-            </a:r>
-            <a:r>
-              <a:rPr lang="en-IN" dirty="0" err="1" smtClean="0"/>
-              <a:t>verify_integrity</a:t>
-            </a:r>
-            <a:r>
-              <a:rPr lang="en-IN" dirty="0" smtClean="0"/>
-              <a:t>=False, sort=False</a:t>
-            </a:r>
-            <a:r>
-              <a:rPr lang="en-IN" dirty="0"/>
-              <a:t>, copy=True)</a:t>
-            </a:r>
-          </a:p>
-        </p:txBody>
-      </p:sp>
-    </p:spTree>
-    <p:extLst>
-      <p:ext uri="{BB962C8B-B14F-4D97-AF65-F5344CB8AC3E}">
-        <p14:creationId xmlns:p14="http://schemas.microsoft.com/office/powerpoint/2010/main" val="2049936089"/>
-      </p:ext>
-    </p:extLst>
-  </p:cSld>
-  <p:clrMapOvr>
-    <a:masterClrMapping/>
-  </p:clrMapOvr>
-</p:sld>
-</file>
-
 <file path=ppt/slides/slide12.xml><?xml version="1.0" encoding="utf-8"?>
 <p:sld xmlns:a="http://schemas.openxmlformats.org/drawingml/2006/main" xmlns:r="http://schemas.openxmlformats.org/officeDocument/2006/relationships" xmlns:p="http://schemas.openxmlformats.org/presentationml/2006/main">
   <p:cSld>
@@ -4037,843 +4763,97 @@
       </p:grpSpPr>
       <p:sp>
         <p:nvSpPr>
-          <p:cNvPr id="4" name="Rectangle 3"/>
-          <p:cNvSpPr/>
-          <p:nvPr/>
-        </p:nvSpPr>
-        <p:spPr>
-          <a:xfrm>
-            <a:off x="389744" y="135948"/>
-            <a:ext cx="4167266" cy="4524315"/>
-          </a:xfrm>
-          <a:prstGeom prst="rect">
-            <a:avLst/>
-          </a:prstGeom>
-        </p:spPr>
-        <p:txBody>
-          <a:bodyPr wrap="square">
-            <a:spAutoFit/>
-          </a:bodyPr>
+          <p:cNvPr id="2" name="Title 1"/>
+          <p:cNvSpPr>
+            <a:spLocks noGrp="1"/>
+          </p:cNvSpPr>
+          <p:nvPr>
+            <p:ph type="title"/>
+          </p:nvPr>
+        </p:nvSpPr>
+        <p:spPr/>
+        <p:txBody>
+          <a:bodyPr/>
           <a:lstStyle/>
           <a:p>
             <a:r>
+              <a:rPr lang="en-US" dirty="0" err="1" smtClean="0"/>
+              <a:t>Concat</a:t>
+            </a:r>
+            <a:r>
+              <a:rPr lang="en-US" dirty="0" smtClean="0"/>
+              <a:t>()</a:t>
+            </a:r>
+            <a:endParaRPr lang="en-IN" dirty="0"/>
+          </a:p>
+        </p:txBody>
+      </p:sp>
+      <p:sp>
+        <p:nvSpPr>
+          <p:cNvPr id="3" name="Content Placeholder 2"/>
+          <p:cNvSpPr>
+            <a:spLocks noGrp="1"/>
+          </p:cNvSpPr>
+          <p:nvPr>
+            <p:ph idx="1"/>
+          </p:nvPr>
+        </p:nvSpPr>
+        <p:spPr/>
+        <p:txBody>
+          <a:bodyPr/>
+          <a:lstStyle/>
+          <a:p>
+            <a:r>
+              <a:rPr lang="en-IN" dirty="0" err="1"/>
+              <a:t>pd.concat</a:t>
+            </a:r>
+            <a:r>
               <a:rPr lang="en-IN" dirty="0"/>
-              <a:t># Student basic info</a:t>
-            </a:r>
-          </a:p>
-          <a:p>
+              <a:t>(</a:t>
+            </a:r>
+            <a:r>
+              <a:rPr lang="en-IN" dirty="0" err="1"/>
+              <a:t>objs</a:t>
+            </a:r>
             <a:r>
               <a:rPr lang="en-IN" dirty="0"/>
-              <a:t>df1 = </a:t>
+              <a:t>, axis=0, join='outer', </a:t>
             </a:r>
             <a:r>
               <a:rPr lang="en-IN" dirty="0" err="1"/>
-              <a:t>pd.DataFrame</a:t>
+              <a:t>ignore_index</a:t>
             </a:r>
             <a:r>
               <a:rPr lang="en-IN" dirty="0"/>
-              <a:t>({</a:t>
-            </a:r>
-          </a:p>
-          <a:p>
+              <a:t>=False</a:t>
+            </a:r>
+            <a:r>
+              <a:rPr lang="en-IN" dirty="0" smtClean="0"/>
+              <a:t>,  </a:t>
+            </a:r>
             <a:r>
               <a:rPr lang="en-IN" dirty="0"/>
-              <a:t>    '</a:t>
-            </a:r>
-            <a:r>
-              <a:rPr lang="en-IN" dirty="0" err="1"/>
-              <a:t>roll_no</a:t>
+              <a:t>keys=None, levels=None, names=None, </a:t>
+            </a:r>
+            <a:r>
+              <a:rPr lang="en-IN" dirty="0" err="1" smtClean="0"/>
+              <a:t>verify_integrity</a:t>
+            </a:r>
+            <a:r>
+              <a:rPr lang="en-IN" dirty="0" smtClean="0"/>
+              <a:t>=False, sort=False</a:t>
             </a:r>
             <a:r>
               <a:rPr lang="en-IN" dirty="0"/>
-              <a:t>': [1, 2, 3],</a:t>
-            </a:r>
-          </a:p>
-          <a:p>
-            <a:r>
-              <a:rPr lang="en-IN" dirty="0"/>
-              <a:t>    'name': ['Alice', 'Bob', 'Charlie']</a:t>
-            </a:r>
-          </a:p>
-          <a:p>
-            <a:r>
-              <a:rPr lang="en-IN" dirty="0" smtClean="0"/>
-              <a:t>})</a:t>
-            </a:r>
-            <a:endParaRPr lang="en-US" dirty="0" smtClean="0"/>
-          </a:p>
-          <a:p>
-            <a:endParaRPr lang="en-IN" dirty="0"/>
-          </a:p>
-          <a:p>
-            <a:r>
-              <a:rPr lang="en-IN" dirty="0"/>
-              <a:t># Student marks info</a:t>
-            </a:r>
-          </a:p>
-          <a:p>
-            <a:r>
-              <a:rPr lang="en-IN" dirty="0"/>
-              <a:t>df2 = </a:t>
-            </a:r>
-            <a:r>
-              <a:rPr lang="en-IN" dirty="0" err="1"/>
-              <a:t>pd.DataFrame</a:t>
-            </a:r>
-            <a:r>
-              <a:rPr lang="en-IN" dirty="0"/>
-              <a:t>({</a:t>
-            </a:r>
-          </a:p>
-          <a:p>
-            <a:r>
-              <a:rPr lang="en-IN" dirty="0"/>
-              <a:t>    '</a:t>
-            </a:r>
-            <a:r>
-              <a:rPr lang="en-IN" dirty="0" err="1"/>
-              <a:t>roll_no</a:t>
-            </a:r>
-            <a:r>
-              <a:rPr lang="en-IN" dirty="0"/>
-              <a:t>': [1, 2, 4],</a:t>
-            </a:r>
-          </a:p>
-          <a:p>
-            <a:r>
-              <a:rPr lang="en-IN" dirty="0"/>
-              <a:t>    'marks': [85, 90, 88]</a:t>
-            </a:r>
-          </a:p>
-          <a:p>
-            <a:r>
-              <a:rPr lang="en-IN" dirty="0"/>
-              <a:t>})</a:t>
-            </a:r>
-          </a:p>
-          <a:p>
-            <a:endParaRPr lang="en-IN" dirty="0"/>
-          </a:p>
-          <a:p>
-            <a:r>
-              <a:rPr lang="en-IN" dirty="0"/>
-              <a:t># Student address info (index-based)</a:t>
-            </a:r>
-          </a:p>
-          <a:p>
-            <a:r>
-              <a:rPr lang="en-IN" dirty="0"/>
-              <a:t>df3 = </a:t>
-            </a:r>
-            <a:r>
-              <a:rPr lang="en-IN" dirty="0" err="1"/>
-              <a:t>pd.DataFrame</a:t>
-            </a:r>
-            <a:r>
-              <a:rPr lang="en-IN" dirty="0"/>
-              <a:t>({</a:t>
-            </a:r>
-          </a:p>
-          <a:p>
-            <a:r>
-              <a:rPr lang="en-IN" dirty="0"/>
-              <a:t>    'address': ['Delhi', 'Mumbai', 'Chennai']</a:t>
-            </a:r>
-          </a:p>
-          <a:p>
-            <a:r>
-              <a:rPr lang="en-IN" dirty="0"/>
-              <a:t>}, index=['Alice', 'Charlie', 'David'])</a:t>
-            </a:r>
-          </a:p>
-        </p:txBody>
-      </p:sp>
-      <p:sp>
-        <p:nvSpPr>
-          <p:cNvPr id="5" name="Rectangle 4"/>
-          <p:cNvSpPr/>
-          <p:nvPr/>
-        </p:nvSpPr>
-        <p:spPr>
-          <a:xfrm>
-            <a:off x="5951096" y="179883"/>
-            <a:ext cx="5801193" cy="369332"/>
-          </a:xfrm>
-          <a:prstGeom prst="rect">
-            <a:avLst/>
-          </a:prstGeom>
-        </p:spPr>
-        <p:txBody>
-          <a:bodyPr wrap="square">
-            <a:spAutoFit/>
-          </a:bodyPr>
-          <a:lstStyle/>
-          <a:p>
-            <a:r>
-              <a:rPr lang="en-IN" b="1" dirty="0" err="1">
-                <a:solidFill>
-                  <a:srgbClr val="7030A0"/>
-                </a:solidFill>
-              </a:rPr>
-              <a:t>merged_df</a:t>
-            </a:r>
-            <a:r>
-              <a:rPr lang="en-IN" b="1" dirty="0">
-                <a:solidFill>
-                  <a:srgbClr val="7030A0"/>
-                </a:solidFill>
-              </a:rPr>
-              <a:t> = </a:t>
-            </a:r>
-            <a:r>
-              <a:rPr lang="en-IN" b="1" dirty="0" err="1">
-                <a:solidFill>
-                  <a:srgbClr val="7030A0"/>
-                </a:solidFill>
-              </a:rPr>
-              <a:t>pd.merge</a:t>
-            </a:r>
-            <a:r>
-              <a:rPr lang="en-IN" b="1" dirty="0">
-                <a:solidFill>
-                  <a:srgbClr val="7030A0"/>
-                </a:solidFill>
-              </a:rPr>
-              <a:t>(df1, df2, on='</a:t>
-            </a:r>
-            <a:r>
-              <a:rPr lang="en-IN" b="1" dirty="0" err="1">
-                <a:solidFill>
-                  <a:srgbClr val="7030A0"/>
-                </a:solidFill>
-              </a:rPr>
-              <a:t>roll_no</a:t>
-            </a:r>
-            <a:r>
-              <a:rPr lang="en-IN" b="1" dirty="0">
-                <a:solidFill>
-                  <a:srgbClr val="7030A0"/>
-                </a:solidFill>
-              </a:rPr>
-              <a:t>', how='inner')</a:t>
-            </a:r>
-          </a:p>
-        </p:txBody>
-      </p:sp>
-      <p:sp>
-        <p:nvSpPr>
-          <p:cNvPr id="6" name="Rectangle 5"/>
-          <p:cNvSpPr/>
-          <p:nvPr/>
-        </p:nvSpPr>
-        <p:spPr>
-          <a:xfrm>
-            <a:off x="5951096" y="688830"/>
-            <a:ext cx="6096000" cy="923330"/>
-          </a:xfrm>
-          <a:prstGeom prst="rect">
-            <a:avLst/>
-          </a:prstGeom>
-        </p:spPr>
-        <p:txBody>
-          <a:bodyPr>
-            <a:spAutoFit/>
-          </a:bodyPr>
-          <a:lstStyle/>
-          <a:p>
-            <a:r>
-              <a:rPr lang="en-IN" dirty="0"/>
-              <a:t> </a:t>
-            </a:r>
-            <a:r>
-              <a:rPr lang="en-IN" dirty="0" err="1"/>
-              <a:t>roll_no</a:t>
-            </a:r>
-            <a:r>
-              <a:rPr lang="en-IN" dirty="0"/>
-              <a:t>    name  marks</a:t>
-            </a:r>
-          </a:p>
-          <a:p>
-            <a:r>
-              <a:rPr lang="en-IN" dirty="0"/>
-              <a:t>0        1  </a:t>
-            </a:r>
-            <a:r>
-              <a:rPr lang="en-IN" dirty="0" smtClean="0"/>
-              <a:t>    Alice   85</a:t>
-            </a:r>
-            <a:endParaRPr lang="en-IN" dirty="0"/>
-          </a:p>
-          <a:p>
-            <a:r>
-              <a:rPr lang="en-IN" dirty="0"/>
-              <a:t>1        2     </a:t>
-            </a:r>
-            <a:r>
-              <a:rPr lang="en-IN" dirty="0" smtClean="0"/>
-              <a:t> Bob     90</a:t>
-            </a:r>
-            <a:endParaRPr lang="en-IN" dirty="0"/>
-          </a:p>
-        </p:txBody>
-      </p:sp>
-      <p:sp>
-        <p:nvSpPr>
-          <p:cNvPr id="7" name="Rectangle 6"/>
-          <p:cNvSpPr/>
-          <p:nvPr/>
-        </p:nvSpPr>
-        <p:spPr>
-          <a:xfrm>
-            <a:off x="5921116" y="1751775"/>
-            <a:ext cx="6096000" cy="646331"/>
-          </a:xfrm>
-          <a:prstGeom prst="rect">
-            <a:avLst/>
-          </a:prstGeom>
-        </p:spPr>
-        <p:txBody>
-          <a:bodyPr>
-            <a:spAutoFit/>
-          </a:bodyPr>
-          <a:lstStyle/>
-          <a:p>
-            <a:r>
-              <a:rPr lang="en-IN" b="1" dirty="0" err="1">
-                <a:solidFill>
-                  <a:srgbClr val="7030A0"/>
-                </a:solidFill>
-              </a:rPr>
-              <a:t>concat_df</a:t>
-            </a:r>
-            <a:r>
-              <a:rPr lang="en-IN" b="1" dirty="0">
-                <a:solidFill>
-                  <a:srgbClr val="7030A0"/>
-                </a:solidFill>
-              </a:rPr>
-              <a:t> = </a:t>
-            </a:r>
-            <a:r>
-              <a:rPr lang="en-IN" b="1" dirty="0" err="1">
-                <a:solidFill>
-                  <a:srgbClr val="7030A0"/>
-                </a:solidFill>
-              </a:rPr>
-              <a:t>pd.concat</a:t>
-            </a:r>
-            <a:r>
-              <a:rPr lang="en-IN" b="1" dirty="0">
-                <a:solidFill>
-                  <a:srgbClr val="7030A0"/>
-                </a:solidFill>
-              </a:rPr>
-              <a:t>([df1, df2], </a:t>
-            </a:r>
-            <a:r>
-              <a:rPr lang="en-IN" b="1" dirty="0" err="1">
-                <a:solidFill>
-                  <a:srgbClr val="7030A0"/>
-                </a:solidFill>
-              </a:rPr>
-              <a:t>ignore_index</a:t>
-            </a:r>
-            <a:r>
-              <a:rPr lang="en-IN" b="1" dirty="0">
-                <a:solidFill>
-                  <a:srgbClr val="7030A0"/>
-                </a:solidFill>
-              </a:rPr>
-              <a:t>=True)</a:t>
-            </a:r>
-          </a:p>
-          <a:p>
-            <a:r>
-              <a:rPr lang="en-IN" b="1" dirty="0">
-                <a:solidFill>
-                  <a:srgbClr val="7030A0"/>
-                </a:solidFill>
-              </a:rPr>
-              <a:t>print("\</a:t>
-            </a:r>
-            <a:r>
-              <a:rPr lang="en-IN" b="1" dirty="0" err="1">
-                <a:solidFill>
-                  <a:srgbClr val="7030A0"/>
-                </a:solidFill>
-              </a:rPr>
-              <a:t>nUsing</a:t>
-            </a:r>
-            <a:r>
-              <a:rPr lang="en-IN" b="1" dirty="0">
-                <a:solidFill>
-                  <a:srgbClr val="7030A0"/>
-                </a:solidFill>
-              </a:rPr>
-              <a:t> </a:t>
-            </a:r>
-            <a:r>
-              <a:rPr lang="en-IN" b="1" dirty="0" err="1">
-                <a:solidFill>
-                  <a:srgbClr val="7030A0"/>
-                </a:solidFill>
-              </a:rPr>
-              <a:t>concat</a:t>
-            </a:r>
-            <a:r>
-              <a:rPr lang="en-IN" b="1" dirty="0">
-                <a:solidFill>
-                  <a:srgbClr val="7030A0"/>
-                </a:solidFill>
-              </a:rPr>
-              <a:t>() - Vertical:")</a:t>
-            </a:r>
-          </a:p>
-        </p:txBody>
-      </p:sp>
-      <p:sp>
-        <p:nvSpPr>
-          <p:cNvPr id="8" name="Rectangle 7"/>
-          <p:cNvSpPr/>
-          <p:nvPr/>
-        </p:nvSpPr>
-        <p:spPr>
-          <a:xfrm>
-            <a:off x="5951096" y="2585003"/>
-            <a:ext cx="6096000" cy="2031325"/>
-          </a:xfrm>
-          <a:prstGeom prst="rect">
-            <a:avLst/>
-          </a:prstGeom>
-        </p:spPr>
-        <p:txBody>
-          <a:bodyPr>
-            <a:spAutoFit/>
-          </a:bodyPr>
-          <a:lstStyle/>
-          <a:p>
-            <a:r>
-              <a:rPr lang="en-IN" dirty="0"/>
-              <a:t> </a:t>
-            </a:r>
-            <a:r>
-              <a:rPr lang="en-IN" dirty="0" err="1"/>
-              <a:t>roll_no</a:t>
-            </a:r>
-            <a:r>
-              <a:rPr lang="en-IN" dirty="0"/>
-              <a:t>     name  marks</a:t>
-            </a:r>
-          </a:p>
-          <a:p>
-            <a:r>
-              <a:rPr lang="en-IN" dirty="0"/>
-              <a:t>0      1.0    Alice    </a:t>
-            </a:r>
-            <a:r>
-              <a:rPr lang="en-IN" dirty="0" err="1"/>
-              <a:t>NaN</a:t>
-            </a:r>
-            <a:endParaRPr lang="en-IN" dirty="0"/>
-          </a:p>
-          <a:p>
-            <a:r>
-              <a:rPr lang="en-IN" dirty="0"/>
-              <a:t>1      2.0      Bob    </a:t>
-            </a:r>
-            <a:r>
-              <a:rPr lang="en-IN" dirty="0" err="1"/>
-              <a:t>NaN</a:t>
-            </a:r>
-            <a:endParaRPr lang="en-IN" dirty="0"/>
-          </a:p>
-          <a:p>
-            <a:r>
-              <a:rPr lang="en-IN" dirty="0"/>
-              <a:t>2      3.0  Charlie    </a:t>
-            </a:r>
-            <a:r>
-              <a:rPr lang="en-IN" dirty="0" err="1"/>
-              <a:t>NaN</a:t>
-            </a:r>
-            <a:endParaRPr lang="en-IN" dirty="0"/>
-          </a:p>
-          <a:p>
-            <a:r>
-              <a:rPr lang="en-IN" dirty="0"/>
-              <a:t>3      1.0      </a:t>
-            </a:r>
-            <a:r>
-              <a:rPr lang="en-IN" dirty="0" err="1"/>
-              <a:t>NaN</a:t>
-            </a:r>
-            <a:r>
-              <a:rPr lang="en-IN" dirty="0"/>
-              <a:t>   85.0</a:t>
-            </a:r>
-          </a:p>
-          <a:p>
-            <a:r>
-              <a:rPr lang="en-IN" dirty="0"/>
-              <a:t>4      2.0      </a:t>
-            </a:r>
-            <a:r>
-              <a:rPr lang="en-IN" dirty="0" err="1"/>
-              <a:t>NaN</a:t>
-            </a:r>
-            <a:r>
-              <a:rPr lang="en-IN" dirty="0"/>
-              <a:t>   90.0</a:t>
-            </a:r>
-          </a:p>
-          <a:p>
-            <a:r>
-              <a:rPr lang="en-IN" dirty="0"/>
-              <a:t>5      4.0      </a:t>
-            </a:r>
-            <a:r>
-              <a:rPr lang="en-IN" dirty="0" err="1"/>
-              <a:t>NaN</a:t>
-            </a:r>
-            <a:r>
-              <a:rPr lang="en-IN" dirty="0"/>
-              <a:t>   88.0</a:t>
-            </a:r>
-          </a:p>
-        </p:txBody>
-      </p:sp>
-      <p:sp>
-        <p:nvSpPr>
-          <p:cNvPr id="9" name="Rectangle 8"/>
-          <p:cNvSpPr/>
-          <p:nvPr/>
-        </p:nvSpPr>
-        <p:spPr>
-          <a:xfrm>
-            <a:off x="5951096" y="4803225"/>
-            <a:ext cx="6096000" cy="646331"/>
-          </a:xfrm>
-          <a:prstGeom prst="rect">
-            <a:avLst/>
-          </a:prstGeom>
-        </p:spPr>
-        <p:txBody>
-          <a:bodyPr>
-            <a:spAutoFit/>
-          </a:bodyPr>
-          <a:lstStyle/>
-          <a:p>
-            <a:r>
-              <a:rPr lang="en-IN" b="1" dirty="0" err="1">
-                <a:solidFill>
-                  <a:srgbClr val="7030A0"/>
-                </a:solidFill>
-              </a:rPr>
-              <a:t>concat_df_col</a:t>
-            </a:r>
-            <a:r>
-              <a:rPr lang="en-IN" b="1" dirty="0">
-                <a:solidFill>
-                  <a:srgbClr val="7030A0"/>
-                </a:solidFill>
-              </a:rPr>
-              <a:t> = </a:t>
-            </a:r>
-            <a:r>
-              <a:rPr lang="en-IN" b="1" dirty="0" err="1">
-                <a:solidFill>
-                  <a:srgbClr val="7030A0"/>
-                </a:solidFill>
-              </a:rPr>
-              <a:t>pd.concat</a:t>
-            </a:r>
-            <a:r>
-              <a:rPr lang="en-IN" b="1" dirty="0">
-                <a:solidFill>
-                  <a:srgbClr val="7030A0"/>
-                </a:solidFill>
-              </a:rPr>
-              <a:t>([df1, df2], axis=1)</a:t>
-            </a:r>
-          </a:p>
-          <a:p>
-            <a:r>
-              <a:rPr lang="en-IN" b="1" dirty="0">
-                <a:solidFill>
-                  <a:srgbClr val="7030A0"/>
-                </a:solidFill>
-              </a:rPr>
-              <a:t>print("\</a:t>
-            </a:r>
-            <a:r>
-              <a:rPr lang="en-IN" b="1" dirty="0" err="1">
-                <a:solidFill>
-                  <a:srgbClr val="7030A0"/>
-                </a:solidFill>
-              </a:rPr>
-              <a:t>nUsing</a:t>
-            </a:r>
-            <a:r>
-              <a:rPr lang="en-IN" b="1" dirty="0">
-                <a:solidFill>
-                  <a:srgbClr val="7030A0"/>
-                </a:solidFill>
-              </a:rPr>
-              <a:t> </a:t>
-            </a:r>
-            <a:r>
-              <a:rPr lang="en-IN" b="1" dirty="0" err="1">
-                <a:solidFill>
-                  <a:srgbClr val="7030A0"/>
-                </a:solidFill>
-              </a:rPr>
-              <a:t>concat</a:t>
-            </a:r>
-            <a:r>
-              <a:rPr lang="en-IN" b="1" dirty="0">
-                <a:solidFill>
-                  <a:srgbClr val="7030A0"/>
-                </a:solidFill>
-              </a:rPr>
-              <a:t>() - Horizontal:")</a:t>
-            </a:r>
-          </a:p>
-        </p:txBody>
-      </p:sp>
-      <p:sp>
-        <p:nvSpPr>
-          <p:cNvPr id="10" name="Rectangle 9"/>
-          <p:cNvSpPr/>
-          <p:nvPr/>
-        </p:nvSpPr>
-        <p:spPr>
-          <a:xfrm>
-            <a:off x="5951096" y="5589171"/>
-            <a:ext cx="6096000" cy="1200329"/>
-          </a:xfrm>
-          <a:prstGeom prst="rect">
-            <a:avLst/>
-          </a:prstGeom>
-        </p:spPr>
-        <p:txBody>
-          <a:bodyPr>
-            <a:spAutoFit/>
-          </a:bodyPr>
-          <a:lstStyle/>
-          <a:p>
-            <a:r>
-              <a:rPr lang="en-IN" dirty="0"/>
-              <a:t> </a:t>
-            </a:r>
-            <a:r>
-              <a:rPr lang="en-IN" dirty="0" smtClean="0"/>
-              <a:t>    </a:t>
-            </a:r>
-            <a:r>
-              <a:rPr lang="en-IN" dirty="0" err="1" smtClean="0"/>
-              <a:t>roll_no</a:t>
-            </a:r>
-            <a:r>
-              <a:rPr lang="en-IN" dirty="0" smtClean="0"/>
-              <a:t>     </a:t>
-            </a:r>
-            <a:r>
-              <a:rPr lang="en-IN" dirty="0"/>
-              <a:t>name  </a:t>
-            </a:r>
-            <a:r>
-              <a:rPr lang="en-IN" dirty="0" smtClean="0"/>
-              <a:t>   </a:t>
-            </a:r>
-            <a:r>
-              <a:rPr lang="en-IN" dirty="0" err="1" smtClean="0"/>
-              <a:t>roll_no</a:t>
-            </a:r>
-            <a:r>
-              <a:rPr lang="en-IN" dirty="0" smtClean="0"/>
-              <a:t>  </a:t>
-            </a:r>
-            <a:r>
-              <a:rPr lang="en-IN" dirty="0"/>
-              <a:t>marks</a:t>
-            </a:r>
-          </a:p>
-          <a:p>
-            <a:r>
-              <a:rPr lang="en-IN" dirty="0"/>
-              <a:t>0        1    </a:t>
-            </a:r>
-            <a:r>
-              <a:rPr lang="en-IN" dirty="0" smtClean="0"/>
-              <a:t>       Alice          1          85</a:t>
-            </a:r>
-            <a:endParaRPr lang="en-IN" dirty="0"/>
-          </a:p>
-          <a:p>
-            <a:r>
-              <a:rPr lang="en-IN" dirty="0"/>
-              <a:t>1        2      </a:t>
-            </a:r>
-            <a:r>
-              <a:rPr lang="en-IN" dirty="0" smtClean="0"/>
-              <a:t>     Bob            2          90</a:t>
-            </a:r>
-            <a:endParaRPr lang="en-IN" dirty="0"/>
-          </a:p>
-          <a:p>
-            <a:r>
-              <a:rPr lang="en-IN" dirty="0"/>
-              <a:t>2        3  </a:t>
-            </a:r>
-            <a:r>
-              <a:rPr lang="en-IN" dirty="0" smtClean="0"/>
-              <a:t>         Charlie       </a:t>
-            </a:r>
-            <a:r>
-              <a:rPr lang="en-IN" dirty="0"/>
-              <a:t>4     </a:t>
-            </a:r>
-            <a:r>
-              <a:rPr lang="en-IN" dirty="0" smtClean="0"/>
-              <a:t>     88</a:t>
-            </a:r>
-            <a:endParaRPr lang="en-IN" dirty="0"/>
-          </a:p>
-        </p:txBody>
-      </p:sp>
-      <p:sp>
-        <p:nvSpPr>
-          <p:cNvPr id="11" name="Rectangle 10"/>
-          <p:cNvSpPr/>
-          <p:nvPr/>
-        </p:nvSpPr>
-        <p:spPr>
-          <a:xfrm>
-            <a:off x="494675" y="4941724"/>
-            <a:ext cx="4463081" cy="369332"/>
-          </a:xfrm>
-          <a:prstGeom prst="rect">
-            <a:avLst/>
-          </a:prstGeom>
-        </p:spPr>
-        <p:txBody>
-          <a:bodyPr wrap="none">
-            <a:spAutoFit/>
-          </a:bodyPr>
-          <a:lstStyle/>
-          <a:p>
-            <a:r>
-              <a:rPr lang="en-IN" b="1" dirty="0" err="1">
-                <a:solidFill>
-                  <a:srgbClr val="7030A0"/>
-                </a:solidFill>
-              </a:rPr>
-              <a:t>joined_df</a:t>
-            </a:r>
-            <a:r>
-              <a:rPr lang="en-IN" b="1" dirty="0">
-                <a:solidFill>
-                  <a:srgbClr val="7030A0"/>
-                </a:solidFill>
-              </a:rPr>
-              <a:t> = df1_indexed.join(df3, how='left')</a:t>
-            </a:r>
-          </a:p>
-        </p:txBody>
-      </p:sp>
-      <p:sp>
-        <p:nvSpPr>
-          <p:cNvPr id="12" name="Rectangle 11"/>
-          <p:cNvSpPr/>
-          <p:nvPr/>
-        </p:nvSpPr>
-        <p:spPr>
-          <a:xfrm>
-            <a:off x="389744" y="5292393"/>
-            <a:ext cx="6096000" cy="1477328"/>
-          </a:xfrm>
-          <a:prstGeom prst="rect">
-            <a:avLst/>
-          </a:prstGeom>
-        </p:spPr>
-        <p:txBody>
-          <a:bodyPr>
-            <a:spAutoFit/>
-          </a:bodyPr>
-          <a:lstStyle/>
-          <a:p>
-            <a:r>
-              <a:rPr lang="en-IN" dirty="0"/>
-              <a:t> </a:t>
-            </a:r>
-            <a:r>
-              <a:rPr lang="en-IN" dirty="0" smtClean="0"/>
-              <a:t>            </a:t>
-            </a:r>
-            <a:r>
-              <a:rPr lang="en-IN" dirty="0" err="1" smtClean="0"/>
-              <a:t>roll_no</a:t>
-            </a:r>
-            <a:r>
-              <a:rPr lang="en-IN" dirty="0"/>
-              <a:t> </a:t>
-            </a:r>
-            <a:r>
-              <a:rPr lang="en-IN" dirty="0" smtClean="0"/>
-              <a:t>  address</a:t>
-            </a:r>
-            <a:endParaRPr lang="en-IN" dirty="0"/>
-          </a:p>
-          <a:p>
-            <a:r>
-              <a:rPr lang="en-IN" dirty="0"/>
-              <a:t>name                     </a:t>
-            </a:r>
-          </a:p>
-          <a:p>
-            <a:r>
-              <a:rPr lang="en-IN" dirty="0"/>
-              <a:t>Alice         </a:t>
-            </a:r>
-            <a:r>
-              <a:rPr lang="en-IN" dirty="0" smtClean="0"/>
-              <a:t>1          Delhi</a:t>
-            </a:r>
-            <a:endParaRPr lang="en-IN" dirty="0"/>
-          </a:p>
-          <a:p>
-            <a:r>
-              <a:rPr lang="en-IN" dirty="0"/>
-              <a:t>Bob          </a:t>
-            </a:r>
-            <a:r>
-              <a:rPr lang="en-IN" dirty="0" smtClean="0"/>
-              <a:t> 2          </a:t>
-            </a:r>
-            <a:r>
-              <a:rPr lang="en-IN" dirty="0" err="1" smtClean="0"/>
-              <a:t>NaN</a:t>
-            </a:r>
-            <a:endParaRPr lang="en-IN" dirty="0"/>
-          </a:p>
-          <a:p>
-            <a:r>
-              <a:rPr lang="en-IN" dirty="0"/>
-              <a:t>Charlie    </a:t>
-            </a:r>
-            <a:r>
-              <a:rPr lang="en-IN" dirty="0" smtClean="0"/>
-              <a:t> 3          Mumbai</a:t>
-            </a:r>
-            <a:endParaRPr lang="en-IN" dirty="0"/>
+              <a:t>, copy=True)</a:t>
+            </a:r>
           </a:p>
         </p:txBody>
       </p:sp>
     </p:spTree>
     <p:extLst>
       <p:ext uri="{BB962C8B-B14F-4D97-AF65-F5344CB8AC3E}">
-        <p14:creationId xmlns:p14="http://schemas.microsoft.com/office/powerpoint/2010/main" val="1264799897"/>
+        <p14:creationId xmlns:p14="http://schemas.microsoft.com/office/powerpoint/2010/main" val="2049936089"/>
       </p:ext>
     </p:extLst>
   </p:cSld>
@@ -4902,6 +4882,871 @@
       </p:grpSpPr>
       <p:sp>
         <p:nvSpPr>
+          <p:cNvPr id="4" name="Rectangle 3"/>
+          <p:cNvSpPr/>
+          <p:nvPr/>
+        </p:nvSpPr>
+        <p:spPr>
+          <a:xfrm>
+            <a:off x="389744" y="135948"/>
+            <a:ext cx="4167266" cy="4524315"/>
+          </a:xfrm>
+          <a:prstGeom prst="rect">
+            <a:avLst/>
+          </a:prstGeom>
+        </p:spPr>
+        <p:txBody>
+          <a:bodyPr wrap="square">
+            <a:spAutoFit/>
+          </a:bodyPr>
+          <a:lstStyle/>
+          <a:p>
+            <a:r>
+              <a:rPr lang="en-IN" dirty="0"/>
+              <a:t># Student basic info</a:t>
+            </a:r>
+          </a:p>
+          <a:p>
+            <a:r>
+              <a:rPr lang="en-IN" dirty="0"/>
+              <a:t>df1 = </a:t>
+            </a:r>
+            <a:r>
+              <a:rPr lang="en-IN" dirty="0" err="1"/>
+              <a:t>pd.DataFrame</a:t>
+            </a:r>
+            <a:r>
+              <a:rPr lang="en-IN" dirty="0"/>
+              <a:t>({</a:t>
+            </a:r>
+          </a:p>
+          <a:p>
+            <a:r>
+              <a:rPr lang="en-IN" dirty="0"/>
+              <a:t>    '</a:t>
+            </a:r>
+            <a:r>
+              <a:rPr lang="en-IN" dirty="0" err="1"/>
+              <a:t>roll_no</a:t>
+            </a:r>
+            <a:r>
+              <a:rPr lang="en-IN" dirty="0"/>
+              <a:t>': [1, 2, 3],</a:t>
+            </a:r>
+          </a:p>
+          <a:p>
+            <a:r>
+              <a:rPr lang="en-IN" dirty="0"/>
+              <a:t>    'name': ['Alice', 'Bob', 'Charlie']</a:t>
+            </a:r>
+          </a:p>
+          <a:p>
+            <a:r>
+              <a:rPr lang="en-IN" dirty="0" smtClean="0"/>
+              <a:t>})</a:t>
+            </a:r>
+            <a:endParaRPr lang="en-US" dirty="0" smtClean="0"/>
+          </a:p>
+          <a:p>
+            <a:endParaRPr lang="en-IN" dirty="0"/>
+          </a:p>
+          <a:p>
+            <a:r>
+              <a:rPr lang="en-IN" dirty="0"/>
+              <a:t># Student marks info</a:t>
+            </a:r>
+          </a:p>
+          <a:p>
+            <a:r>
+              <a:rPr lang="en-IN" dirty="0"/>
+              <a:t>df2 = </a:t>
+            </a:r>
+            <a:r>
+              <a:rPr lang="en-IN" dirty="0" err="1"/>
+              <a:t>pd.DataFrame</a:t>
+            </a:r>
+            <a:r>
+              <a:rPr lang="en-IN" dirty="0"/>
+              <a:t>({</a:t>
+            </a:r>
+          </a:p>
+          <a:p>
+            <a:r>
+              <a:rPr lang="en-IN" dirty="0"/>
+              <a:t>    '</a:t>
+            </a:r>
+            <a:r>
+              <a:rPr lang="en-IN" dirty="0" err="1"/>
+              <a:t>roll_no</a:t>
+            </a:r>
+            <a:r>
+              <a:rPr lang="en-IN" dirty="0"/>
+              <a:t>': [1, 2, 4],</a:t>
+            </a:r>
+          </a:p>
+          <a:p>
+            <a:r>
+              <a:rPr lang="en-IN" dirty="0"/>
+              <a:t>    'marks': [85, 90, 88]</a:t>
+            </a:r>
+          </a:p>
+          <a:p>
+            <a:r>
+              <a:rPr lang="en-IN" dirty="0"/>
+              <a:t>})</a:t>
+            </a:r>
+          </a:p>
+          <a:p>
+            <a:endParaRPr lang="en-IN" dirty="0"/>
+          </a:p>
+          <a:p>
+            <a:r>
+              <a:rPr lang="en-IN" dirty="0"/>
+              <a:t># Student address info (index-based)</a:t>
+            </a:r>
+          </a:p>
+          <a:p>
+            <a:r>
+              <a:rPr lang="en-IN" dirty="0"/>
+              <a:t>df3 = </a:t>
+            </a:r>
+            <a:r>
+              <a:rPr lang="en-IN" dirty="0" err="1"/>
+              <a:t>pd.DataFrame</a:t>
+            </a:r>
+            <a:r>
+              <a:rPr lang="en-IN" dirty="0"/>
+              <a:t>({</a:t>
+            </a:r>
+          </a:p>
+          <a:p>
+            <a:r>
+              <a:rPr lang="en-IN" dirty="0"/>
+              <a:t>    'address': ['Delhi', 'Mumbai', 'Chennai']</a:t>
+            </a:r>
+          </a:p>
+          <a:p>
+            <a:r>
+              <a:rPr lang="en-IN" dirty="0"/>
+              <a:t>}, index=['Alice', 'Charlie', 'David'])</a:t>
+            </a:r>
+          </a:p>
+        </p:txBody>
+      </p:sp>
+      <p:sp>
+        <p:nvSpPr>
+          <p:cNvPr id="5" name="Rectangle 4"/>
+          <p:cNvSpPr/>
+          <p:nvPr/>
+        </p:nvSpPr>
+        <p:spPr>
+          <a:xfrm>
+            <a:off x="5951096" y="179883"/>
+            <a:ext cx="5801193" cy="369332"/>
+          </a:xfrm>
+          <a:prstGeom prst="rect">
+            <a:avLst/>
+          </a:prstGeom>
+        </p:spPr>
+        <p:txBody>
+          <a:bodyPr wrap="square">
+            <a:spAutoFit/>
+          </a:bodyPr>
+          <a:lstStyle/>
+          <a:p>
+            <a:r>
+              <a:rPr lang="en-IN" b="1" dirty="0" err="1">
+                <a:solidFill>
+                  <a:srgbClr val="7030A0"/>
+                </a:solidFill>
+              </a:rPr>
+              <a:t>merged_df</a:t>
+            </a:r>
+            <a:r>
+              <a:rPr lang="en-IN" b="1" dirty="0">
+                <a:solidFill>
+                  <a:srgbClr val="7030A0"/>
+                </a:solidFill>
+              </a:rPr>
+              <a:t> = </a:t>
+            </a:r>
+            <a:r>
+              <a:rPr lang="en-IN" b="1" dirty="0" err="1">
+                <a:solidFill>
+                  <a:srgbClr val="7030A0"/>
+                </a:solidFill>
+              </a:rPr>
+              <a:t>pd.merge</a:t>
+            </a:r>
+            <a:r>
+              <a:rPr lang="en-IN" b="1" dirty="0">
+                <a:solidFill>
+                  <a:srgbClr val="7030A0"/>
+                </a:solidFill>
+              </a:rPr>
+              <a:t>(df1, df2, on='</a:t>
+            </a:r>
+            <a:r>
+              <a:rPr lang="en-IN" b="1" dirty="0" err="1">
+                <a:solidFill>
+                  <a:srgbClr val="7030A0"/>
+                </a:solidFill>
+              </a:rPr>
+              <a:t>roll_no</a:t>
+            </a:r>
+            <a:r>
+              <a:rPr lang="en-IN" b="1" dirty="0">
+                <a:solidFill>
+                  <a:srgbClr val="7030A0"/>
+                </a:solidFill>
+              </a:rPr>
+              <a:t>', how='inner')</a:t>
+            </a:r>
+          </a:p>
+        </p:txBody>
+      </p:sp>
+      <p:sp>
+        <p:nvSpPr>
+          <p:cNvPr id="6" name="Rectangle 5"/>
+          <p:cNvSpPr/>
+          <p:nvPr/>
+        </p:nvSpPr>
+        <p:spPr>
+          <a:xfrm>
+            <a:off x="5951096" y="688830"/>
+            <a:ext cx="6096000" cy="923330"/>
+          </a:xfrm>
+          <a:prstGeom prst="rect">
+            <a:avLst/>
+          </a:prstGeom>
+        </p:spPr>
+        <p:txBody>
+          <a:bodyPr>
+            <a:spAutoFit/>
+          </a:bodyPr>
+          <a:lstStyle/>
+          <a:p>
+            <a:r>
+              <a:rPr lang="en-IN" dirty="0"/>
+              <a:t> </a:t>
+            </a:r>
+            <a:r>
+              <a:rPr lang="en-IN" dirty="0" err="1"/>
+              <a:t>roll_no</a:t>
+            </a:r>
+            <a:r>
+              <a:rPr lang="en-IN" dirty="0"/>
+              <a:t>    name  marks</a:t>
+            </a:r>
+          </a:p>
+          <a:p>
+            <a:r>
+              <a:rPr lang="en-IN" dirty="0"/>
+              <a:t>0        1  </a:t>
+            </a:r>
+            <a:r>
+              <a:rPr lang="en-IN" dirty="0" smtClean="0"/>
+              <a:t>    Alice   85</a:t>
+            </a:r>
+            <a:endParaRPr lang="en-IN" dirty="0"/>
+          </a:p>
+          <a:p>
+            <a:r>
+              <a:rPr lang="en-IN" dirty="0"/>
+              <a:t>1        2     </a:t>
+            </a:r>
+            <a:r>
+              <a:rPr lang="en-IN" dirty="0" smtClean="0"/>
+              <a:t> Bob     90</a:t>
+            </a:r>
+            <a:endParaRPr lang="en-IN" dirty="0"/>
+          </a:p>
+        </p:txBody>
+      </p:sp>
+      <p:sp>
+        <p:nvSpPr>
+          <p:cNvPr id="7" name="Rectangle 6"/>
+          <p:cNvSpPr/>
+          <p:nvPr/>
+        </p:nvSpPr>
+        <p:spPr>
+          <a:xfrm>
+            <a:off x="5921116" y="1751775"/>
+            <a:ext cx="6096000" cy="646331"/>
+          </a:xfrm>
+          <a:prstGeom prst="rect">
+            <a:avLst/>
+          </a:prstGeom>
+        </p:spPr>
+        <p:txBody>
+          <a:bodyPr>
+            <a:spAutoFit/>
+          </a:bodyPr>
+          <a:lstStyle/>
+          <a:p>
+            <a:r>
+              <a:rPr lang="en-IN" b="1" dirty="0" err="1">
+                <a:solidFill>
+                  <a:srgbClr val="7030A0"/>
+                </a:solidFill>
+              </a:rPr>
+              <a:t>concat_df</a:t>
+            </a:r>
+            <a:r>
+              <a:rPr lang="en-IN" b="1" dirty="0">
+                <a:solidFill>
+                  <a:srgbClr val="7030A0"/>
+                </a:solidFill>
+              </a:rPr>
+              <a:t> = </a:t>
+            </a:r>
+            <a:r>
+              <a:rPr lang="en-IN" b="1" dirty="0" err="1">
+                <a:solidFill>
+                  <a:srgbClr val="7030A0"/>
+                </a:solidFill>
+              </a:rPr>
+              <a:t>pd.concat</a:t>
+            </a:r>
+            <a:r>
+              <a:rPr lang="en-IN" b="1" dirty="0">
+                <a:solidFill>
+                  <a:srgbClr val="7030A0"/>
+                </a:solidFill>
+              </a:rPr>
+              <a:t>([df1, df2], </a:t>
+            </a:r>
+            <a:r>
+              <a:rPr lang="en-IN" b="1" dirty="0" err="1">
+                <a:solidFill>
+                  <a:srgbClr val="7030A0"/>
+                </a:solidFill>
+              </a:rPr>
+              <a:t>ignore_index</a:t>
+            </a:r>
+            <a:r>
+              <a:rPr lang="en-IN" b="1" dirty="0">
+                <a:solidFill>
+                  <a:srgbClr val="7030A0"/>
+                </a:solidFill>
+              </a:rPr>
+              <a:t>=True)</a:t>
+            </a:r>
+          </a:p>
+          <a:p>
+            <a:r>
+              <a:rPr lang="en-IN" b="1" dirty="0">
+                <a:solidFill>
+                  <a:srgbClr val="7030A0"/>
+                </a:solidFill>
+              </a:rPr>
+              <a:t>print("\</a:t>
+            </a:r>
+            <a:r>
+              <a:rPr lang="en-IN" b="1" dirty="0" err="1">
+                <a:solidFill>
+                  <a:srgbClr val="7030A0"/>
+                </a:solidFill>
+              </a:rPr>
+              <a:t>nUsing</a:t>
+            </a:r>
+            <a:r>
+              <a:rPr lang="en-IN" b="1" dirty="0">
+                <a:solidFill>
+                  <a:srgbClr val="7030A0"/>
+                </a:solidFill>
+              </a:rPr>
+              <a:t> </a:t>
+            </a:r>
+            <a:r>
+              <a:rPr lang="en-IN" b="1" dirty="0" err="1">
+                <a:solidFill>
+                  <a:srgbClr val="7030A0"/>
+                </a:solidFill>
+              </a:rPr>
+              <a:t>concat</a:t>
+            </a:r>
+            <a:r>
+              <a:rPr lang="en-IN" b="1" dirty="0">
+                <a:solidFill>
+                  <a:srgbClr val="7030A0"/>
+                </a:solidFill>
+              </a:rPr>
+              <a:t>() - Vertical:")</a:t>
+            </a:r>
+          </a:p>
+        </p:txBody>
+      </p:sp>
+      <p:sp>
+        <p:nvSpPr>
+          <p:cNvPr id="8" name="Rectangle 7"/>
+          <p:cNvSpPr/>
+          <p:nvPr/>
+        </p:nvSpPr>
+        <p:spPr>
+          <a:xfrm>
+            <a:off x="5951096" y="2585003"/>
+            <a:ext cx="6096000" cy="2031325"/>
+          </a:xfrm>
+          <a:prstGeom prst="rect">
+            <a:avLst/>
+          </a:prstGeom>
+        </p:spPr>
+        <p:txBody>
+          <a:bodyPr>
+            <a:spAutoFit/>
+          </a:bodyPr>
+          <a:lstStyle/>
+          <a:p>
+            <a:r>
+              <a:rPr lang="en-IN" dirty="0"/>
+              <a:t> </a:t>
+            </a:r>
+            <a:r>
+              <a:rPr lang="en-IN" dirty="0" err="1"/>
+              <a:t>roll_no</a:t>
+            </a:r>
+            <a:r>
+              <a:rPr lang="en-IN" dirty="0"/>
+              <a:t>     name  marks</a:t>
+            </a:r>
+          </a:p>
+          <a:p>
+            <a:r>
+              <a:rPr lang="en-IN" dirty="0"/>
+              <a:t>0      1.0    Alice    </a:t>
+            </a:r>
+            <a:r>
+              <a:rPr lang="en-IN" dirty="0" err="1"/>
+              <a:t>NaN</a:t>
+            </a:r>
+            <a:endParaRPr lang="en-IN" dirty="0"/>
+          </a:p>
+          <a:p>
+            <a:r>
+              <a:rPr lang="en-IN" dirty="0"/>
+              <a:t>1      2.0      Bob    </a:t>
+            </a:r>
+            <a:r>
+              <a:rPr lang="en-IN" dirty="0" err="1"/>
+              <a:t>NaN</a:t>
+            </a:r>
+            <a:endParaRPr lang="en-IN" dirty="0"/>
+          </a:p>
+          <a:p>
+            <a:r>
+              <a:rPr lang="en-IN" dirty="0"/>
+              <a:t>2      3.0  Charlie    </a:t>
+            </a:r>
+            <a:r>
+              <a:rPr lang="en-IN" dirty="0" err="1"/>
+              <a:t>NaN</a:t>
+            </a:r>
+            <a:endParaRPr lang="en-IN" dirty="0"/>
+          </a:p>
+          <a:p>
+            <a:r>
+              <a:rPr lang="en-IN" dirty="0"/>
+              <a:t>3      1.0      </a:t>
+            </a:r>
+            <a:r>
+              <a:rPr lang="en-IN" dirty="0" err="1"/>
+              <a:t>NaN</a:t>
+            </a:r>
+            <a:r>
+              <a:rPr lang="en-IN" dirty="0"/>
+              <a:t>   85.0</a:t>
+            </a:r>
+          </a:p>
+          <a:p>
+            <a:r>
+              <a:rPr lang="en-IN" dirty="0"/>
+              <a:t>4      2.0      </a:t>
+            </a:r>
+            <a:r>
+              <a:rPr lang="en-IN" dirty="0" err="1"/>
+              <a:t>NaN</a:t>
+            </a:r>
+            <a:r>
+              <a:rPr lang="en-IN" dirty="0"/>
+              <a:t>   90.0</a:t>
+            </a:r>
+          </a:p>
+          <a:p>
+            <a:r>
+              <a:rPr lang="en-IN" dirty="0"/>
+              <a:t>5      4.0      </a:t>
+            </a:r>
+            <a:r>
+              <a:rPr lang="en-IN" dirty="0" err="1"/>
+              <a:t>NaN</a:t>
+            </a:r>
+            <a:r>
+              <a:rPr lang="en-IN" dirty="0"/>
+              <a:t>   88.0</a:t>
+            </a:r>
+          </a:p>
+        </p:txBody>
+      </p:sp>
+      <p:sp>
+        <p:nvSpPr>
+          <p:cNvPr id="9" name="Rectangle 8"/>
+          <p:cNvSpPr/>
+          <p:nvPr/>
+        </p:nvSpPr>
+        <p:spPr>
+          <a:xfrm>
+            <a:off x="5951096" y="4803225"/>
+            <a:ext cx="6096000" cy="646331"/>
+          </a:xfrm>
+          <a:prstGeom prst="rect">
+            <a:avLst/>
+          </a:prstGeom>
+        </p:spPr>
+        <p:txBody>
+          <a:bodyPr>
+            <a:spAutoFit/>
+          </a:bodyPr>
+          <a:lstStyle/>
+          <a:p>
+            <a:r>
+              <a:rPr lang="en-IN" b="1" dirty="0" err="1">
+                <a:solidFill>
+                  <a:srgbClr val="7030A0"/>
+                </a:solidFill>
+              </a:rPr>
+              <a:t>concat_df_col</a:t>
+            </a:r>
+            <a:r>
+              <a:rPr lang="en-IN" b="1" dirty="0">
+                <a:solidFill>
+                  <a:srgbClr val="7030A0"/>
+                </a:solidFill>
+              </a:rPr>
+              <a:t> = </a:t>
+            </a:r>
+            <a:r>
+              <a:rPr lang="en-IN" b="1" dirty="0" err="1">
+                <a:solidFill>
+                  <a:srgbClr val="7030A0"/>
+                </a:solidFill>
+              </a:rPr>
+              <a:t>pd.concat</a:t>
+            </a:r>
+            <a:r>
+              <a:rPr lang="en-IN" b="1" dirty="0">
+                <a:solidFill>
+                  <a:srgbClr val="7030A0"/>
+                </a:solidFill>
+              </a:rPr>
+              <a:t>([df1, df2], axis=1)</a:t>
+            </a:r>
+          </a:p>
+          <a:p>
+            <a:r>
+              <a:rPr lang="en-IN" b="1" dirty="0">
+                <a:solidFill>
+                  <a:srgbClr val="7030A0"/>
+                </a:solidFill>
+              </a:rPr>
+              <a:t>print("\</a:t>
+            </a:r>
+            <a:r>
+              <a:rPr lang="en-IN" b="1" dirty="0" err="1">
+                <a:solidFill>
+                  <a:srgbClr val="7030A0"/>
+                </a:solidFill>
+              </a:rPr>
+              <a:t>nUsing</a:t>
+            </a:r>
+            <a:r>
+              <a:rPr lang="en-IN" b="1" dirty="0">
+                <a:solidFill>
+                  <a:srgbClr val="7030A0"/>
+                </a:solidFill>
+              </a:rPr>
+              <a:t> </a:t>
+            </a:r>
+            <a:r>
+              <a:rPr lang="en-IN" b="1" dirty="0" err="1">
+                <a:solidFill>
+                  <a:srgbClr val="7030A0"/>
+                </a:solidFill>
+              </a:rPr>
+              <a:t>concat</a:t>
+            </a:r>
+            <a:r>
+              <a:rPr lang="en-IN" b="1" dirty="0">
+                <a:solidFill>
+                  <a:srgbClr val="7030A0"/>
+                </a:solidFill>
+              </a:rPr>
+              <a:t>() - Horizontal:")</a:t>
+            </a:r>
+          </a:p>
+        </p:txBody>
+      </p:sp>
+      <p:sp>
+        <p:nvSpPr>
+          <p:cNvPr id="10" name="Rectangle 9"/>
+          <p:cNvSpPr/>
+          <p:nvPr/>
+        </p:nvSpPr>
+        <p:spPr>
+          <a:xfrm>
+            <a:off x="5951096" y="5589171"/>
+            <a:ext cx="6096000" cy="1200329"/>
+          </a:xfrm>
+          <a:prstGeom prst="rect">
+            <a:avLst/>
+          </a:prstGeom>
+        </p:spPr>
+        <p:txBody>
+          <a:bodyPr>
+            <a:spAutoFit/>
+          </a:bodyPr>
+          <a:lstStyle/>
+          <a:p>
+            <a:r>
+              <a:rPr lang="en-IN" dirty="0"/>
+              <a:t> </a:t>
+            </a:r>
+            <a:r>
+              <a:rPr lang="en-IN" dirty="0" smtClean="0"/>
+              <a:t>    </a:t>
+            </a:r>
+            <a:r>
+              <a:rPr lang="en-IN" dirty="0" err="1" smtClean="0"/>
+              <a:t>roll_no</a:t>
+            </a:r>
+            <a:r>
+              <a:rPr lang="en-IN" dirty="0" smtClean="0"/>
+              <a:t>     </a:t>
+            </a:r>
+            <a:r>
+              <a:rPr lang="en-IN" dirty="0"/>
+              <a:t>name  </a:t>
+            </a:r>
+            <a:r>
+              <a:rPr lang="en-IN" dirty="0" smtClean="0"/>
+              <a:t>   </a:t>
+            </a:r>
+            <a:r>
+              <a:rPr lang="en-IN" dirty="0" err="1" smtClean="0"/>
+              <a:t>roll_no</a:t>
+            </a:r>
+            <a:r>
+              <a:rPr lang="en-IN" dirty="0" smtClean="0"/>
+              <a:t>  </a:t>
+            </a:r>
+            <a:r>
+              <a:rPr lang="en-IN" dirty="0"/>
+              <a:t>marks</a:t>
+            </a:r>
+          </a:p>
+          <a:p>
+            <a:r>
+              <a:rPr lang="en-IN" dirty="0"/>
+              <a:t>0        1    </a:t>
+            </a:r>
+            <a:r>
+              <a:rPr lang="en-IN" dirty="0" smtClean="0"/>
+              <a:t>       Alice          1          85</a:t>
+            </a:r>
+            <a:endParaRPr lang="en-IN" dirty="0"/>
+          </a:p>
+          <a:p>
+            <a:r>
+              <a:rPr lang="en-IN" dirty="0"/>
+              <a:t>1        2      </a:t>
+            </a:r>
+            <a:r>
+              <a:rPr lang="en-IN" dirty="0" smtClean="0"/>
+              <a:t>     Bob            2          90</a:t>
+            </a:r>
+            <a:endParaRPr lang="en-IN" dirty="0"/>
+          </a:p>
+          <a:p>
+            <a:r>
+              <a:rPr lang="en-IN" dirty="0"/>
+              <a:t>2        3  </a:t>
+            </a:r>
+            <a:r>
+              <a:rPr lang="en-IN" dirty="0" smtClean="0"/>
+              <a:t>         Charlie       </a:t>
+            </a:r>
+            <a:r>
+              <a:rPr lang="en-IN" dirty="0"/>
+              <a:t>4     </a:t>
+            </a:r>
+            <a:r>
+              <a:rPr lang="en-IN" dirty="0" smtClean="0"/>
+              <a:t>     88</a:t>
+            </a:r>
+            <a:endParaRPr lang="en-IN" dirty="0"/>
+          </a:p>
+        </p:txBody>
+      </p:sp>
+      <p:sp>
+        <p:nvSpPr>
+          <p:cNvPr id="11" name="Rectangle 10"/>
+          <p:cNvSpPr/>
+          <p:nvPr/>
+        </p:nvSpPr>
+        <p:spPr>
+          <a:xfrm>
+            <a:off x="494675" y="4941724"/>
+            <a:ext cx="4463081" cy="369332"/>
+          </a:xfrm>
+          <a:prstGeom prst="rect">
+            <a:avLst/>
+          </a:prstGeom>
+        </p:spPr>
+        <p:txBody>
+          <a:bodyPr wrap="none">
+            <a:spAutoFit/>
+          </a:bodyPr>
+          <a:lstStyle/>
+          <a:p>
+            <a:r>
+              <a:rPr lang="en-IN" b="1" dirty="0" err="1">
+                <a:solidFill>
+                  <a:srgbClr val="7030A0"/>
+                </a:solidFill>
+              </a:rPr>
+              <a:t>joined_df</a:t>
+            </a:r>
+            <a:r>
+              <a:rPr lang="en-IN" b="1" dirty="0">
+                <a:solidFill>
+                  <a:srgbClr val="7030A0"/>
+                </a:solidFill>
+              </a:rPr>
+              <a:t> = df1_indexed.join(df3, how='left')</a:t>
+            </a:r>
+          </a:p>
+        </p:txBody>
+      </p:sp>
+      <p:sp>
+        <p:nvSpPr>
+          <p:cNvPr id="12" name="Rectangle 11"/>
+          <p:cNvSpPr/>
+          <p:nvPr/>
+        </p:nvSpPr>
+        <p:spPr>
+          <a:xfrm>
+            <a:off x="389744" y="5292393"/>
+            <a:ext cx="6096000" cy="1477328"/>
+          </a:xfrm>
+          <a:prstGeom prst="rect">
+            <a:avLst/>
+          </a:prstGeom>
+        </p:spPr>
+        <p:txBody>
+          <a:bodyPr>
+            <a:spAutoFit/>
+          </a:bodyPr>
+          <a:lstStyle/>
+          <a:p>
+            <a:r>
+              <a:rPr lang="en-IN" dirty="0"/>
+              <a:t> </a:t>
+            </a:r>
+            <a:r>
+              <a:rPr lang="en-IN" dirty="0" smtClean="0"/>
+              <a:t>            </a:t>
+            </a:r>
+            <a:r>
+              <a:rPr lang="en-IN" dirty="0" err="1" smtClean="0"/>
+              <a:t>roll_no</a:t>
+            </a:r>
+            <a:r>
+              <a:rPr lang="en-IN" dirty="0"/>
+              <a:t> </a:t>
+            </a:r>
+            <a:r>
+              <a:rPr lang="en-IN" dirty="0" smtClean="0"/>
+              <a:t>  address</a:t>
+            </a:r>
+            <a:endParaRPr lang="en-IN" dirty="0"/>
+          </a:p>
+          <a:p>
+            <a:r>
+              <a:rPr lang="en-IN" dirty="0"/>
+              <a:t>name                     </a:t>
+            </a:r>
+          </a:p>
+          <a:p>
+            <a:r>
+              <a:rPr lang="en-IN" dirty="0"/>
+              <a:t>Alice         </a:t>
+            </a:r>
+            <a:r>
+              <a:rPr lang="en-IN" dirty="0" smtClean="0"/>
+              <a:t>1          Delhi</a:t>
+            </a:r>
+            <a:endParaRPr lang="en-IN" dirty="0"/>
+          </a:p>
+          <a:p>
+            <a:r>
+              <a:rPr lang="en-IN" dirty="0"/>
+              <a:t>Bob          </a:t>
+            </a:r>
+            <a:r>
+              <a:rPr lang="en-IN" dirty="0" smtClean="0"/>
+              <a:t> 2          </a:t>
+            </a:r>
+            <a:r>
+              <a:rPr lang="en-IN" dirty="0" err="1" smtClean="0"/>
+              <a:t>NaN</a:t>
+            </a:r>
+            <a:endParaRPr lang="en-IN" dirty="0"/>
+          </a:p>
+          <a:p>
+            <a:r>
+              <a:rPr lang="en-IN" dirty="0"/>
+              <a:t>Charlie    </a:t>
+            </a:r>
+            <a:r>
+              <a:rPr lang="en-IN" dirty="0" smtClean="0"/>
+              <a:t> 3          Mumbai</a:t>
+            </a:r>
+            <a:endParaRPr lang="en-IN" dirty="0"/>
+          </a:p>
+        </p:txBody>
+      </p:sp>
+    </p:spTree>
+    <p:extLst>
+      <p:ext uri="{BB962C8B-B14F-4D97-AF65-F5344CB8AC3E}">
+        <p14:creationId xmlns:p14="http://schemas.microsoft.com/office/powerpoint/2010/main" val="1264799897"/>
+      </p:ext>
+    </p:extLst>
+  </p:cSld>
+  <p:clrMapOvr>
+    <a:masterClrMapping/>
+  </p:clrMapOvr>
+</p:sld>
+</file>
+
+<file path=ppt/slides/slide14.xml><?xml version="1.0" encoding="utf-8"?>
+<p:sld xmlns:a="http://schemas.openxmlformats.org/drawingml/2006/main" xmlns:r="http://schemas.openxmlformats.org/officeDocument/2006/relationships" xmlns:p="http://schemas.openxmlformats.org/presentationml/2006/main">
+  <p:cSld>
+    <p:spTree>
+      <p:nvGrpSpPr>
+        <p:cNvPr id="1" name=""/>
+        <p:cNvGrpSpPr/>
+        <p:nvPr/>
+      </p:nvGrpSpPr>
+      <p:grpSpPr>
+        <a:xfrm>
+          <a:off x="0" y="0"/>
+          <a:ext cx="0" cy="0"/>
+          <a:chOff x="0" y="0"/>
+          <a:chExt cx="0" cy="0"/>
+        </a:xfrm>
+      </p:grpSpPr>
+      <p:sp>
+        <p:nvSpPr>
           <p:cNvPr id="2" name="Title 1"/>
           <p:cNvSpPr>
             <a:spLocks noGrp="1"/>
@@ -5197,7 +6042,7 @@
 </p:sld>
 </file>
 
-<file path=ppt/slides/slide14.xml><?xml version="1.0" encoding="utf-8"?>
+<file path=ppt/slides/slide15.xml><?xml version="1.0" encoding="utf-8"?>
 <p:sld xmlns:a="http://schemas.openxmlformats.org/drawingml/2006/main" xmlns:r="http://schemas.openxmlformats.org/officeDocument/2006/relationships" xmlns:p="http://schemas.openxmlformats.org/presentationml/2006/main">
   <p:cSld>
     <p:spTree>
@@ -6618,7 +7463,7 @@
           <p:cNvPr id="4" name="Content Placeholder 2">
             <a:extLst>
               <a:ext uri="{FF2B5EF4-FFF2-40B4-BE49-F238E27FC236}">
-                <a16:creationId xmlns="" xmlns:a16="http://schemas.microsoft.com/office/drawing/2014/main" id="{1143BD24-5912-5F32-5088-94B762CA3F92}"/>
+                <a16:creationId xmlns:a16="http://schemas.microsoft.com/office/drawing/2014/main" xmlns="" id="{1143BD24-5912-5F32-5088-94B762CA3F92}"/>
               </a:ext>
             </a:extLst>
           </p:cNvPr>
@@ -6952,7 +7797,7 @@
           <p:cNvPr id="5" name="Title 1">
             <a:extLst>
               <a:ext uri="{FF2B5EF4-FFF2-40B4-BE49-F238E27FC236}">
-                <a16:creationId xmlns="" xmlns:a16="http://schemas.microsoft.com/office/drawing/2014/main" id="{6456B49A-562D-3DAA-896C-300530521C53}"/>
+                <a16:creationId xmlns:a16="http://schemas.microsoft.com/office/drawing/2014/main" xmlns="" id="{6456B49A-562D-3DAA-896C-300530521C53}"/>
               </a:ext>
             </a:extLst>
           </p:cNvPr>
@@ -7030,10 +7875,33 @@
             <p:ph type="title"/>
           </p:nvPr>
         </p:nvSpPr>
+        <p:spPr/>
+        <p:txBody>
+          <a:bodyPr/>
+          <a:lstStyle/>
+          <a:p>
+            <a:r>
+              <a:rPr lang="en-US" smtClean="0"/>
+              <a:t>Group By</a:t>
+            </a:r>
+            <a:endParaRPr lang="en-IN" dirty="0"/>
+          </a:p>
+        </p:txBody>
+      </p:sp>
+      <p:sp>
+        <p:nvSpPr>
+          <p:cNvPr id="3" name="Content Placeholder 2"/>
+          <p:cNvSpPr>
+            <a:spLocks noGrp="1"/>
+          </p:cNvSpPr>
+          <p:nvPr>
+            <p:ph idx="1"/>
+          </p:nvPr>
+        </p:nvSpPr>
         <p:spPr>
           <a:xfrm>
-            <a:off x="479685" y="140212"/>
-            <a:ext cx="11422505" cy="1325563"/>
+            <a:off x="359764" y="1825625"/>
+            <a:ext cx="10994036" cy="4351338"/>
           </a:xfrm>
         </p:spPr>
         <p:txBody>
@@ -7041,803 +7909,160 @@
           <a:lstStyle/>
           <a:p>
             <a:r>
+              <a:rPr lang="en-US" dirty="0" err="1"/>
+              <a:t>d</a:t>
+            </a:r>
+            <a:r>
+              <a:rPr lang="en-US" dirty="0" err="1" smtClean="0"/>
+              <a:t>f.groupby</a:t>
+            </a:r>
+            <a:r>
               <a:rPr lang="en-US" dirty="0" smtClean="0"/>
-              <a:t>Merge(),  Join() and </a:t>
+              <a:t>(‘aggregate column’)[‘</a:t>
             </a:r>
             <a:r>
               <a:rPr lang="en-US" dirty="0" err="1" smtClean="0"/>
-              <a:t>Concat</a:t>
+              <a:t>column_name</a:t>
             </a:r>
             <a:r>
               <a:rPr lang="en-US" dirty="0" smtClean="0"/>
-              <a:t>() </a:t>
+              <a:t>’].aggregate function()</a:t>
+            </a:r>
+          </a:p>
+          <a:p>
+            <a:pPr marL="0" indent="0">
+              <a:buNone/>
+            </a:pPr>
+            <a:r>
+              <a:rPr lang="en-IN" dirty="0" err="1" smtClean="0"/>
+              <a:t>eg</a:t>
+            </a:r>
+            <a:r>
+              <a:rPr lang="en-IN" dirty="0" smtClean="0"/>
+              <a:t>.</a:t>
+            </a:r>
+          </a:p>
+          <a:p>
+            <a:pPr marL="0" indent="0">
+              <a:buNone/>
+            </a:pPr>
+            <a:r>
+              <a:rPr lang="en-IN" dirty="0" smtClean="0"/>
+              <a:t>print(</a:t>
+            </a:r>
+            <a:r>
+              <a:rPr lang="en-IN" dirty="0" err="1" smtClean="0"/>
+              <a:t>df.groupby</a:t>
+            </a:r>
+            <a:r>
+              <a:rPr lang="en-IN" dirty="0"/>
+              <a:t>('Department')['Percentage'].mean())</a:t>
+            </a:r>
+          </a:p>
+          <a:p>
+            <a:pPr marL="0" indent="0">
+              <a:buNone/>
+            </a:pPr>
+            <a:r>
+              <a:rPr lang="en-IN" dirty="0"/>
+              <a:t>print(</a:t>
+            </a:r>
+            <a:r>
+              <a:rPr lang="en-IN" dirty="0" err="1"/>
+              <a:t>df.groupby</a:t>
+            </a:r>
+            <a:r>
+              <a:rPr lang="en-IN" dirty="0"/>
+              <a:t>('Department')[['</a:t>
+            </a:r>
+            <a:r>
+              <a:rPr lang="en-IN" dirty="0" err="1"/>
+              <a:t>Percentage','Attendance</a:t>
+            </a:r>
+            <a:r>
+              <a:rPr lang="en-IN" dirty="0"/>
+              <a:t>']].mean</a:t>
+            </a:r>
+            <a:r>
+              <a:rPr lang="en-IN" dirty="0" smtClean="0"/>
+              <a:t>())</a:t>
+            </a:r>
+          </a:p>
+          <a:p>
+            <a:pPr marL="0" indent="0">
+              <a:buNone/>
+            </a:pPr>
+            <a:endParaRPr lang="en-US" dirty="0"/>
+          </a:p>
+          <a:p>
+            <a:pPr marL="0" indent="0">
+              <a:buNone/>
+            </a:pPr>
+            <a:r>
+              <a:rPr lang="en-US" dirty="0"/>
+              <a:t>result = </a:t>
+            </a:r>
+            <a:r>
+              <a:rPr lang="en-US" dirty="0" err="1"/>
+              <a:t>df.groupby</a:t>
+            </a:r>
+            <a:r>
+              <a:rPr lang="en-US" dirty="0"/>
+              <a:t>("Department</a:t>
+            </a:r>
+            <a:r>
+              <a:rPr lang="en-US" dirty="0" smtClean="0"/>
+              <a:t>")</a:t>
+            </a:r>
+          </a:p>
+          <a:p>
+            <a:pPr marL="0" indent="0">
+              <a:buNone/>
+            </a:pPr>
+            <a:r>
+              <a:rPr lang="en-US" dirty="0"/>
+              <a:t>	</a:t>
+            </a:r>
+            <a:r>
+              <a:rPr lang="en-US" dirty="0" smtClean="0"/>
+              <a:t>.</a:t>
             </a:r>
             <a:r>
               <a:rPr lang="en-US" dirty="0" err="1" smtClean="0"/>
-              <a:t>Dataframe</a:t>
+              <a:t>agg</a:t>
+            </a:r>
+            <a:r>
+              <a:rPr lang="en-US" dirty="0" smtClean="0"/>
+              <a:t>(</a:t>
+            </a:r>
+            <a:r>
+              <a:rPr lang="en-US" dirty="0" err="1" smtClean="0"/>
+              <a:t>Min_Marks</a:t>
+            </a:r>
+            <a:r>
+              <a:rPr lang="en-US" dirty="0"/>
+              <a:t>=("Marks", "min"),    </a:t>
+            </a:r>
+            <a:r>
+              <a:rPr lang="en-US" dirty="0" smtClean="0"/>
+              <a:t>					 	        </a:t>
+            </a:r>
+            <a:r>
+              <a:rPr lang="en-US" dirty="0" err="1" smtClean="0"/>
+              <a:t>Max_Attendance</a:t>
+            </a:r>
+            <a:r>
+              <a:rPr lang="en-US" dirty="0"/>
+              <a:t>=("Attendance", "max"))</a:t>
             </a:r>
             <a:endParaRPr lang="en-IN" dirty="0"/>
-          </a:p>
-        </p:txBody>
-      </p:sp>
-      <p:graphicFrame>
-        <p:nvGraphicFramePr>
-          <p:cNvPr id="4" name="Content Placeholder 3"/>
-          <p:cNvGraphicFramePr>
-            <a:graphicFrameLocks noGrp="1"/>
-          </p:cNvGraphicFramePr>
-          <p:nvPr>
-            <p:ph idx="1"/>
-            <p:extLst>
-              <p:ext uri="{D42A27DB-BD31-4B8C-83A1-F6EECF244321}">
-                <p14:modId xmlns:p14="http://schemas.microsoft.com/office/powerpoint/2010/main" val="1161266127"/>
-              </p:ext>
-            </p:extLst>
-          </p:nvPr>
-        </p:nvGraphicFramePr>
-        <p:xfrm>
-          <a:off x="599608" y="2401093"/>
-          <a:ext cx="11302584" cy="4089649"/>
-        </p:xfrm>
-        <a:graphic>
-          <a:graphicData uri="http://schemas.openxmlformats.org/drawingml/2006/table">
-            <a:tbl>
-              <a:tblPr/>
-              <a:tblGrid>
-                <a:gridCol w="1873769"/>
-                <a:gridCol w="3507698"/>
-                <a:gridCol w="3095471"/>
-                <a:gridCol w="2825646"/>
-              </a:tblGrid>
-              <a:tr h="467389">
-                <a:tc>
-                  <a:txBody>
-                    <a:bodyPr/>
-                    <a:lstStyle/>
-                    <a:p>
-                      <a:r>
-                        <a:rPr lang="en-IN" b="1" dirty="0">
-                          <a:latin typeface="Times New Roman" panose="02020603050405020304" pitchFamily="18" charset="0"/>
-                          <a:cs typeface="Times New Roman" panose="02020603050405020304" pitchFamily="18" charset="0"/>
-                        </a:rPr>
-                        <a:t>Feature</a:t>
-                      </a:r>
-                    </a:p>
-                  </a:txBody>
-                  <a:tcPr anchor="ctr">
-                    <a:lnL>
-                      <a:noFill/>
-                    </a:lnL>
-                    <a:lnR>
-                      <a:noFill/>
-                    </a:lnR>
-                    <a:lnT>
-                      <a:noFill/>
-                    </a:lnT>
-                    <a:lnB>
-                      <a:noFill/>
-                    </a:lnB>
-                  </a:tcPr>
-                </a:tc>
-                <a:tc>
-                  <a:txBody>
-                    <a:bodyPr/>
-                    <a:lstStyle/>
-                    <a:p>
-                      <a:r>
-                        <a:rPr lang="en-IN" b="1" dirty="0">
-                          <a:latin typeface="Times New Roman" panose="02020603050405020304" pitchFamily="18" charset="0"/>
-                          <a:cs typeface="Times New Roman" panose="02020603050405020304" pitchFamily="18" charset="0"/>
-                        </a:rPr>
-                        <a:t>merge()</a:t>
-                      </a:r>
-                    </a:p>
-                  </a:txBody>
-                  <a:tcPr anchor="ctr">
-                    <a:lnL>
-                      <a:noFill/>
-                    </a:lnL>
-                    <a:lnR>
-                      <a:noFill/>
-                    </a:lnR>
-                    <a:lnT>
-                      <a:noFill/>
-                    </a:lnT>
-                    <a:lnB>
-                      <a:noFill/>
-                    </a:lnB>
-                  </a:tcPr>
-                </a:tc>
-                <a:tc>
-                  <a:txBody>
-                    <a:bodyPr/>
-                    <a:lstStyle/>
-                    <a:p>
-                      <a:r>
-                        <a:rPr lang="en-IN" b="1" dirty="0" err="1">
-                          <a:latin typeface="Times New Roman" panose="02020603050405020304" pitchFamily="18" charset="0"/>
-                          <a:cs typeface="Times New Roman" panose="02020603050405020304" pitchFamily="18" charset="0"/>
-                        </a:rPr>
-                        <a:t>concat</a:t>
-                      </a:r>
-                      <a:r>
-                        <a:rPr lang="en-IN" b="1" dirty="0">
-                          <a:latin typeface="Times New Roman" panose="02020603050405020304" pitchFamily="18" charset="0"/>
-                          <a:cs typeface="Times New Roman" panose="02020603050405020304" pitchFamily="18" charset="0"/>
-                        </a:rPr>
-                        <a:t>()</a:t>
-                      </a:r>
-                    </a:p>
-                  </a:txBody>
-                  <a:tcPr anchor="ctr">
-                    <a:lnL>
-                      <a:noFill/>
-                    </a:lnL>
-                    <a:lnR>
-                      <a:noFill/>
-                    </a:lnR>
-                    <a:lnT>
-                      <a:noFill/>
-                    </a:lnT>
-                    <a:lnB>
-                      <a:noFill/>
-                    </a:lnB>
-                  </a:tcPr>
-                </a:tc>
-                <a:tc>
-                  <a:txBody>
-                    <a:bodyPr/>
-                    <a:lstStyle/>
-                    <a:p>
-                      <a:r>
-                        <a:rPr lang="en-IN" b="1" dirty="0">
-                          <a:latin typeface="Times New Roman" panose="02020603050405020304" pitchFamily="18" charset="0"/>
-                          <a:cs typeface="Times New Roman" panose="02020603050405020304" pitchFamily="18" charset="0"/>
-                        </a:rPr>
-                        <a:t>join()</a:t>
-                      </a:r>
-                    </a:p>
-                  </a:txBody>
-                  <a:tcPr anchor="ctr">
-                    <a:lnL>
-                      <a:noFill/>
-                    </a:lnL>
-                    <a:lnR>
-                      <a:noFill/>
-                    </a:lnR>
-                    <a:lnT>
-                      <a:noFill/>
-                    </a:lnT>
-                    <a:lnB>
-                      <a:noFill/>
-                    </a:lnB>
-                  </a:tcPr>
-                </a:tc>
-              </a:tr>
-              <a:tr h="817930">
-                <a:tc>
-                  <a:txBody>
-                    <a:bodyPr/>
-                    <a:lstStyle/>
-                    <a:p>
-                      <a:r>
-                        <a:rPr lang="en-IN" dirty="0">
-                          <a:latin typeface="Times New Roman" panose="02020603050405020304" pitchFamily="18" charset="0"/>
-                          <a:cs typeface="Times New Roman" panose="02020603050405020304" pitchFamily="18" charset="0"/>
-                        </a:rPr>
-                        <a:t>Based On</a:t>
-                      </a:r>
-                    </a:p>
-                  </a:txBody>
-                  <a:tcPr anchor="ctr">
-                    <a:lnL>
-                      <a:noFill/>
-                    </a:lnL>
-                    <a:lnR>
-                      <a:noFill/>
-                    </a:lnR>
-                    <a:lnT>
-                      <a:noFill/>
-                    </a:lnT>
-                    <a:lnB>
-                      <a:noFill/>
-                    </a:lnB>
-                  </a:tcPr>
-                </a:tc>
-                <a:tc>
-                  <a:txBody>
-                    <a:bodyPr/>
-                    <a:lstStyle/>
-                    <a:p>
-                      <a:r>
-                        <a:rPr lang="en-IN">
-                          <a:latin typeface="Times New Roman" panose="02020603050405020304" pitchFamily="18" charset="0"/>
-                          <a:cs typeface="Times New Roman" panose="02020603050405020304" pitchFamily="18" charset="0"/>
-                        </a:rPr>
-                        <a:t>Columns (keys)</a:t>
-                      </a:r>
-                    </a:p>
-                  </a:txBody>
-                  <a:tcPr anchor="ctr">
-                    <a:lnL>
-                      <a:noFill/>
-                    </a:lnL>
-                    <a:lnR>
-                      <a:noFill/>
-                    </a:lnR>
-                    <a:lnT>
-                      <a:noFill/>
-                    </a:lnT>
-                    <a:lnB>
-                      <a:noFill/>
-                    </a:lnB>
-                  </a:tcPr>
-                </a:tc>
-                <a:tc>
-                  <a:txBody>
-                    <a:bodyPr/>
-                    <a:lstStyle/>
-                    <a:p>
-                      <a:r>
-                        <a:rPr lang="en-IN" dirty="0">
-                          <a:latin typeface="Times New Roman" panose="02020603050405020304" pitchFamily="18" charset="0"/>
-                          <a:cs typeface="Times New Roman" panose="02020603050405020304" pitchFamily="18" charset="0"/>
-                        </a:rPr>
-                        <a:t>Axis (rows or columns)</a:t>
-                      </a:r>
-                    </a:p>
-                  </a:txBody>
-                  <a:tcPr anchor="ctr">
-                    <a:lnL>
-                      <a:noFill/>
-                    </a:lnL>
-                    <a:lnR>
-                      <a:noFill/>
-                    </a:lnR>
-                    <a:lnT>
-                      <a:noFill/>
-                    </a:lnT>
-                    <a:lnB>
-                      <a:noFill/>
-                    </a:lnB>
-                  </a:tcPr>
-                </a:tc>
-                <a:tc>
-                  <a:txBody>
-                    <a:bodyPr/>
-                    <a:lstStyle/>
-                    <a:p>
-                      <a:r>
-                        <a:rPr lang="en-US">
-                          <a:latin typeface="Times New Roman" panose="02020603050405020304" pitchFamily="18" charset="0"/>
-                          <a:cs typeface="Times New Roman" panose="02020603050405020304" pitchFamily="18" charset="0"/>
-                        </a:rPr>
-                        <a:t>Index (by default) or key column</a:t>
-                      </a:r>
-                    </a:p>
-                  </a:txBody>
-                  <a:tcPr anchor="ctr">
-                    <a:lnL>
-                      <a:noFill/>
-                    </a:lnL>
-                    <a:lnR>
-                      <a:noFill/>
-                    </a:lnR>
-                    <a:lnT>
-                      <a:noFill/>
-                    </a:lnT>
-                    <a:lnB>
-                      <a:noFill/>
-                    </a:lnB>
-                  </a:tcPr>
-                </a:tc>
-              </a:tr>
-              <a:tr h="817930">
-                <a:tc>
-                  <a:txBody>
-                    <a:bodyPr/>
-                    <a:lstStyle/>
-                    <a:p>
-                      <a:r>
-                        <a:rPr lang="en-IN">
-                          <a:latin typeface="Times New Roman" panose="02020603050405020304" pitchFamily="18" charset="0"/>
-                          <a:cs typeface="Times New Roman" panose="02020603050405020304" pitchFamily="18" charset="0"/>
-                        </a:rPr>
-                        <a:t>Similar To</a:t>
-                      </a:r>
-                    </a:p>
-                  </a:txBody>
-                  <a:tcPr anchor="ctr">
-                    <a:lnL>
-                      <a:noFill/>
-                    </a:lnL>
-                    <a:lnR>
-                      <a:noFill/>
-                    </a:lnR>
-                    <a:lnT>
-                      <a:noFill/>
-                    </a:lnT>
-                    <a:lnB>
-                      <a:noFill/>
-                    </a:lnB>
-                  </a:tcPr>
-                </a:tc>
-                <a:tc>
-                  <a:txBody>
-                    <a:bodyPr/>
-                    <a:lstStyle/>
-                    <a:p>
-                      <a:r>
-                        <a:rPr lang="en-IN">
-                          <a:latin typeface="Times New Roman" panose="02020603050405020304" pitchFamily="18" charset="0"/>
-                          <a:cs typeface="Times New Roman" panose="02020603050405020304" pitchFamily="18" charset="0"/>
-                        </a:rPr>
-                        <a:t>SQL JOIN</a:t>
-                      </a:r>
-                    </a:p>
-                  </a:txBody>
-                  <a:tcPr anchor="ctr">
-                    <a:lnL>
-                      <a:noFill/>
-                    </a:lnL>
-                    <a:lnR>
-                      <a:noFill/>
-                    </a:lnR>
-                    <a:lnT>
-                      <a:noFill/>
-                    </a:lnT>
-                    <a:lnB>
-                      <a:noFill/>
-                    </a:lnB>
-                  </a:tcPr>
-                </a:tc>
-                <a:tc>
-                  <a:txBody>
-                    <a:bodyPr/>
-                    <a:lstStyle/>
-                    <a:p>
-                      <a:r>
-                        <a:rPr lang="en-IN" dirty="0">
-                          <a:latin typeface="Times New Roman" panose="02020603050405020304" pitchFamily="18" charset="0"/>
-                          <a:cs typeface="Times New Roman" panose="02020603050405020304" pitchFamily="18" charset="0"/>
-                        </a:rPr>
-                        <a:t>Stacking (</a:t>
-                      </a:r>
-                      <a:r>
-                        <a:rPr lang="en-IN" dirty="0" smtClean="0">
-                          <a:latin typeface="Times New Roman" panose="02020603050405020304" pitchFamily="18" charset="0"/>
-                          <a:cs typeface="Times New Roman" panose="02020603050405020304" pitchFamily="18" charset="0"/>
-                        </a:rPr>
-                        <a:t>vertical=0 </a:t>
-                      </a:r>
-                      <a:r>
-                        <a:rPr lang="en-IN" dirty="0">
-                          <a:latin typeface="Times New Roman" panose="02020603050405020304" pitchFamily="18" charset="0"/>
-                          <a:cs typeface="Times New Roman" panose="02020603050405020304" pitchFamily="18" charset="0"/>
-                        </a:rPr>
-                        <a:t>or </a:t>
-                      </a:r>
-                      <a:r>
-                        <a:rPr lang="en-IN" dirty="0" smtClean="0">
-                          <a:latin typeface="Times New Roman" panose="02020603050405020304" pitchFamily="18" charset="0"/>
-                          <a:cs typeface="Times New Roman" panose="02020603050405020304" pitchFamily="18" charset="0"/>
-                        </a:rPr>
-                        <a:t>horizontal=1) using axis</a:t>
-                      </a:r>
-                      <a:endParaRPr lang="en-IN" dirty="0">
-                        <a:latin typeface="Times New Roman" panose="02020603050405020304" pitchFamily="18" charset="0"/>
-                        <a:cs typeface="Times New Roman" panose="02020603050405020304" pitchFamily="18" charset="0"/>
-                      </a:endParaRPr>
-                    </a:p>
-                  </a:txBody>
-                  <a:tcPr anchor="ctr">
-                    <a:lnL>
-                      <a:noFill/>
-                    </a:lnL>
-                    <a:lnR>
-                      <a:noFill/>
-                    </a:lnR>
-                    <a:lnT>
-                      <a:noFill/>
-                    </a:lnT>
-                    <a:lnB>
-                      <a:noFill/>
-                    </a:lnB>
-                  </a:tcPr>
-                </a:tc>
-                <a:tc>
-                  <a:txBody>
-                    <a:bodyPr/>
-                    <a:lstStyle/>
-                    <a:p>
-                      <a:r>
-                        <a:rPr lang="en-IN">
-                          <a:latin typeface="Times New Roman" panose="02020603050405020304" pitchFamily="18" charset="0"/>
-                          <a:cs typeface="Times New Roman" panose="02020603050405020304" pitchFamily="18" charset="0"/>
-                        </a:rPr>
-                        <a:t>SQL JOIN on index</a:t>
-                      </a:r>
-                    </a:p>
-                  </a:txBody>
-                  <a:tcPr anchor="ctr">
-                    <a:lnL>
-                      <a:noFill/>
-                    </a:lnL>
-                    <a:lnR>
-                      <a:noFill/>
-                    </a:lnR>
-                    <a:lnT>
-                      <a:noFill/>
-                    </a:lnT>
-                    <a:lnB>
-                      <a:noFill/>
-                    </a:lnB>
-                  </a:tcPr>
-                </a:tc>
-              </a:tr>
-              <a:tr h="817930">
-                <a:tc>
-                  <a:txBody>
-                    <a:bodyPr/>
-                    <a:lstStyle/>
-                    <a:p>
-                      <a:r>
-                        <a:rPr lang="en-IN">
-                          <a:latin typeface="Times New Roman" panose="02020603050405020304" pitchFamily="18" charset="0"/>
-                          <a:cs typeface="Times New Roman" panose="02020603050405020304" pitchFamily="18" charset="0"/>
-                        </a:rPr>
-                        <a:t>Best Use</a:t>
-                      </a:r>
-                    </a:p>
-                  </a:txBody>
-                  <a:tcPr anchor="ctr">
-                    <a:lnL>
-                      <a:noFill/>
-                    </a:lnL>
-                    <a:lnR>
-                      <a:noFill/>
-                    </a:lnR>
-                    <a:lnT>
-                      <a:noFill/>
-                    </a:lnT>
-                    <a:lnB>
-                      <a:noFill/>
-                    </a:lnB>
-                  </a:tcPr>
-                </a:tc>
-                <a:tc>
-                  <a:txBody>
-                    <a:bodyPr/>
-                    <a:lstStyle/>
-                    <a:p>
-                      <a:r>
-                        <a:rPr lang="en-US">
-                          <a:latin typeface="Times New Roman" panose="02020603050405020304" pitchFamily="18" charset="0"/>
-                          <a:cs typeface="Times New Roman" panose="02020603050405020304" pitchFamily="18" charset="0"/>
-                        </a:rPr>
-                        <a:t>Combining related tables via keys</a:t>
-                      </a:r>
-                    </a:p>
-                  </a:txBody>
-                  <a:tcPr anchor="ctr">
-                    <a:lnL>
-                      <a:noFill/>
-                    </a:lnL>
-                    <a:lnR>
-                      <a:noFill/>
-                    </a:lnR>
-                    <a:lnT>
-                      <a:noFill/>
-                    </a:lnT>
-                    <a:lnB>
-                      <a:noFill/>
-                    </a:lnB>
-                  </a:tcPr>
-                </a:tc>
-                <a:tc>
-                  <a:txBody>
-                    <a:bodyPr/>
-                    <a:lstStyle/>
-                    <a:p>
-                      <a:r>
-                        <a:rPr lang="en-IN">
-                          <a:latin typeface="Times New Roman" panose="02020603050405020304" pitchFamily="18" charset="0"/>
-                          <a:cs typeface="Times New Roman" panose="02020603050405020304" pitchFamily="18" charset="0"/>
-                        </a:rPr>
-                        <a:t>Appending similar datasets</a:t>
-                      </a:r>
-                    </a:p>
-                  </a:txBody>
-                  <a:tcPr anchor="ctr">
-                    <a:lnL>
-                      <a:noFill/>
-                    </a:lnL>
-                    <a:lnR>
-                      <a:noFill/>
-                    </a:lnR>
-                    <a:lnT>
-                      <a:noFill/>
-                    </a:lnT>
-                    <a:lnB>
-                      <a:noFill/>
-                    </a:lnB>
-                  </a:tcPr>
-                </a:tc>
-                <a:tc>
-                  <a:txBody>
-                    <a:bodyPr/>
-                    <a:lstStyle/>
-                    <a:p>
-                      <a:r>
-                        <a:rPr lang="en-IN">
-                          <a:latin typeface="Times New Roman" panose="02020603050405020304" pitchFamily="18" charset="0"/>
-                          <a:cs typeface="Times New Roman" panose="02020603050405020304" pitchFamily="18" charset="0"/>
-                        </a:rPr>
-                        <a:t>Joining on index (simple)</a:t>
-                      </a:r>
-                    </a:p>
-                  </a:txBody>
-                  <a:tcPr anchor="ctr">
-                    <a:lnL>
-                      <a:noFill/>
-                    </a:lnL>
-                    <a:lnR>
-                      <a:noFill/>
-                    </a:lnR>
-                    <a:lnT>
-                      <a:noFill/>
-                    </a:lnT>
-                    <a:lnB>
-                      <a:noFill/>
-                    </a:lnB>
-                  </a:tcPr>
-                </a:tc>
-              </a:tr>
-              <a:tr h="1168470">
-                <a:tc>
-                  <a:txBody>
-                    <a:bodyPr/>
-                    <a:lstStyle/>
-                    <a:p>
-                      <a:r>
-                        <a:rPr lang="en-IN" dirty="0">
-                          <a:latin typeface="Times New Roman" panose="02020603050405020304" pitchFamily="18" charset="0"/>
-                          <a:cs typeface="Times New Roman" panose="02020603050405020304" pitchFamily="18" charset="0"/>
-                        </a:rPr>
-                        <a:t>Flexibility</a:t>
-                      </a:r>
-                    </a:p>
-                  </a:txBody>
-                  <a:tcPr anchor="ctr">
-                    <a:lnL>
-                      <a:noFill/>
-                    </a:lnL>
-                    <a:lnR>
-                      <a:noFill/>
-                    </a:lnR>
-                    <a:lnT>
-                      <a:noFill/>
-                    </a:lnT>
-                    <a:lnB>
-                      <a:noFill/>
-                    </a:lnB>
-                  </a:tcPr>
-                </a:tc>
-                <a:tc>
-                  <a:txBody>
-                    <a:bodyPr/>
-                    <a:lstStyle/>
-                    <a:p>
-                      <a:r>
-                        <a:rPr lang="en-US">
-                          <a:latin typeface="Times New Roman" panose="02020603050405020304" pitchFamily="18" charset="0"/>
-                          <a:cs typeface="Times New Roman" panose="02020603050405020304" pitchFamily="18" charset="0"/>
-                        </a:rPr>
-                        <a:t>High – allows custom join types (inner, outer, left, right)</a:t>
-                      </a:r>
-                    </a:p>
-                  </a:txBody>
-                  <a:tcPr anchor="ctr">
-                    <a:lnL>
-                      <a:noFill/>
-                    </a:lnL>
-                    <a:lnR>
-                      <a:noFill/>
-                    </a:lnR>
-                    <a:lnT>
-                      <a:noFill/>
-                    </a:lnT>
-                    <a:lnB>
-                      <a:noFill/>
-                    </a:lnB>
-                  </a:tcPr>
-                </a:tc>
-                <a:tc>
-                  <a:txBody>
-                    <a:bodyPr/>
-                    <a:lstStyle/>
-                    <a:p>
-                      <a:r>
-                        <a:rPr lang="en-IN">
-                          <a:latin typeface="Times New Roman" panose="02020603050405020304" pitchFamily="18" charset="0"/>
-                          <a:cs typeface="Times New Roman" panose="02020603050405020304" pitchFamily="18" charset="0"/>
-                        </a:rPr>
-                        <a:t>Medium</a:t>
-                      </a:r>
-                    </a:p>
-                  </a:txBody>
-                  <a:tcPr anchor="ctr">
-                    <a:lnL>
-                      <a:noFill/>
-                    </a:lnL>
-                    <a:lnR>
-                      <a:noFill/>
-                    </a:lnR>
-                    <a:lnT>
-                      <a:noFill/>
-                    </a:lnT>
-                    <a:lnB>
-                      <a:noFill/>
-                    </a:lnB>
-                  </a:tcPr>
-                </a:tc>
-                <a:tc>
-                  <a:txBody>
-                    <a:bodyPr/>
-                    <a:lstStyle/>
-                    <a:p>
-                      <a:r>
-                        <a:rPr lang="en-IN" dirty="0">
-                          <a:latin typeface="Times New Roman" panose="02020603050405020304" pitchFamily="18" charset="0"/>
-                          <a:cs typeface="Times New Roman" panose="02020603050405020304" pitchFamily="18" charset="0"/>
-                        </a:rPr>
-                        <a:t>Medium</a:t>
-                      </a:r>
-                    </a:p>
-                  </a:txBody>
-                  <a:tcPr anchor="ctr">
-                    <a:lnL>
-                      <a:noFill/>
-                    </a:lnL>
-                    <a:lnR>
-                      <a:noFill/>
-                    </a:lnR>
-                    <a:lnT>
-                      <a:noFill/>
-                    </a:lnT>
-                    <a:lnB>
-                      <a:noFill/>
-                    </a:lnB>
-                  </a:tcPr>
-                </a:tc>
-              </a:tr>
-            </a:tbl>
-          </a:graphicData>
-        </a:graphic>
-      </p:graphicFrame>
-      <p:sp>
-        <p:nvSpPr>
-          <p:cNvPr id="5" name="Rectangle 1"/>
-          <p:cNvSpPr>
-            <a:spLocks noChangeArrowheads="1"/>
-          </p:cNvSpPr>
-          <p:nvPr/>
-        </p:nvSpPr>
-        <p:spPr bwMode="auto">
-          <a:xfrm>
-            <a:off x="479685" y="1465775"/>
-            <a:ext cx="2444900" cy="707886"/>
-          </a:xfrm>
-          <a:prstGeom prst="rect">
-            <a:avLst/>
-          </a:prstGeom>
-          <a:noFill/>
-          <a:ln>
-            <a:noFill/>
-          </a:ln>
-          <a:effectLst/>
-          <a:extLst>
-            <a:ext uri="{909E8E84-426E-40DD-AFC4-6F175D3DCCD1}">
-              <a14:hiddenFill xmlns:a14="http://schemas.microsoft.com/office/drawing/2010/main">
-                <a:solidFill>
-                  <a:schemeClr val="accent1"/>
-                </a:solidFill>
-              </a14:hiddenFill>
-            </a:ext>
-            <a:ext uri="{91240B29-F687-4F45-9708-019B960494DF}">
-              <a14:hiddenLine xmlns:a14="http://schemas.microsoft.com/office/drawing/2010/main" w="9525">
-                <a:solidFill>
-                  <a:schemeClr val="tx1"/>
-                </a:solidFill>
-                <a:miter lim="800000"/>
-                <a:headEnd/>
-                <a:tailEnd/>
-              </a14:hiddenLine>
-            </a:ext>
-            <a:ext uri="{AF507438-7753-43E0-B8FC-AC1667EBCBE1}">
-              <a14:hiddenEffects xmlns:a14="http://schemas.microsoft.com/office/drawing/2010/main">
-                <a:effectLst>
-                  <a:outerShdw dist="35921" dir="2700000" algn="ctr" rotWithShape="0">
-                    <a:schemeClr val="bg2"/>
-                  </a:outerShdw>
-                </a:effectLst>
-              </a14:hiddenEffects>
-            </a:ext>
-          </a:extLst>
-        </p:spPr>
-        <p:txBody>
-          <a:bodyPr vert="horz" wrap="none" lIns="91440" tIns="45720" rIns="91440" bIns="45720" numCol="1" anchor="ctr" anchorCtr="0" compatLnSpc="1">
-            <a:prstTxWarp prst="textNoShape">
-              <a:avLst/>
-            </a:prstTxWarp>
-            <a:spAutoFit/>
-          </a:bodyPr>
-          <a:lstStyle/>
-          <a:p>
-            <a:pPr marL="0" marR="0" lvl="0" indent="0" algn="l" defTabSz="914400" rtl="0" eaLnBrk="0" fontAlgn="base" latinLnBrk="0" hangingPunct="0">
-              <a:lnSpc>
-                <a:spcPct val="100000"/>
-              </a:lnSpc>
-              <a:spcBef>
-                <a:spcPct val="0"/>
-              </a:spcBef>
-              <a:spcAft>
-                <a:spcPct val="0"/>
-              </a:spcAft>
-              <a:buClrTx/>
-              <a:buSzTx/>
-              <a:buFontTx/>
-              <a:buNone/>
-              <a:tabLst/>
-            </a:pPr>
-            <a:r>
-              <a:rPr kumimoji="0" lang="en-US" sz="2200" b="1" i="0" u="none" strike="noStrike" cap="none" normalizeH="0" baseline="0" dirty="0" smtClean="0">
-                <a:ln>
-                  <a:noFill/>
-                </a:ln>
-                <a:solidFill>
-                  <a:schemeClr val="tx1"/>
-                </a:solidFill>
-                <a:effectLst/>
-                <a:latin typeface="Arial" panose="020B0604020202020204" pitchFamily="34" charset="0"/>
-              </a:rPr>
-              <a:t>Core Differences</a:t>
-            </a:r>
-          </a:p>
-          <a:p>
-            <a:pPr marL="0" marR="0" lvl="0" indent="0" algn="l" defTabSz="914400" rtl="0" eaLnBrk="0" fontAlgn="base" latinLnBrk="0" hangingPunct="0">
-              <a:lnSpc>
-                <a:spcPct val="100000"/>
-              </a:lnSpc>
-              <a:spcBef>
-                <a:spcPct val="0"/>
-              </a:spcBef>
-              <a:spcAft>
-                <a:spcPct val="0"/>
-              </a:spcAft>
-              <a:buClrTx/>
-              <a:buSzTx/>
-              <a:buFontTx/>
-              <a:buNone/>
-              <a:tabLst/>
-            </a:pPr>
-            <a:endParaRPr kumimoji="0" lang="en-US" sz="1800" b="0" i="0" u="none" strike="noStrike" cap="none" normalizeH="0" baseline="0" dirty="0" smtClean="0">
-              <a:ln>
-                <a:noFill/>
-              </a:ln>
-              <a:solidFill>
-                <a:schemeClr val="tx1"/>
-              </a:solidFill>
-              <a:effectLst/>
-              <a:latin typeface="Arial" panose="020B0604020202020204" pitchFamily="34" charset="0"/>
-            </a:endParaRPr>
           </a:p>
         </p:txBody>
       </p:sp>
     </p:spTree>
     <p:extLst>
       <p:ext uri="{BB962C8B-B14F-4D97-AF65-F5344CB8AC3E}">
-        <p14:creationId xmlns:p14="http://schemas.microsoft.com/office/powerpoint/2010/main" val="3729838864"/>
+        <p14:creationId xmlns:p14="http://schemas.microsoft.com/office/powerpoint/2010/main" val="1189502611"/>
       </p:ext>
     </p:extLst>
   </p:cSld>

</xml_diff>